<commit_message>
docs: record verified midpoint results and demo evidence
</commit_message>
<xml_diff>
--- a/docs/midpoint/GroupUNKNOWN-aiplatform.pptx
+++ b/docs/midpoint/GroupUNKNOWN-aiplatform.pptx
@@ -2,20 +2,20 @@
 <file path=ppt/presentation.xml><?xml version="1.0" encoding="utf-8"?>
 <p:presentation xmlns:p="http://schemas.openxmlformats.org/presentationml/2006/main">
   <p:sldMasterIdLst>
-    <p:sldMasterId xmlns:r="http://schemas.openxmlformats.org/officeDocument/2006/relationships" id="2147483648" r:id="Ra182aab201e6457d"/>
+    <p:sldMasterId xmlns:r="http://schemas.openxmlformats.org/officeDocument/2006/relationships" id="2147483648" r:id="R6fd9f31498b247cc"/>
   </p:sldMasterIdLst>
   <p:notesMasterIdLst>
-    <p:notesMasterId xmlns:r="http://schemas.openxmlformats.org/officeDocument/2006/relationships" r:id="Ra123600a738242b7"/>
+    <p:notesMasterId xmlns:r="http://schemas.openxmlformats.org/officeDocument/2006/relationships" r:id="R546c82daeb564b7e"/>
   </p:notesMasterIdLst>
   <p:sldIdLst>
-    <p:sldId xmlns:r="http://schemas.openxmlformats.org/officeDocument/2006/relationships" id="256" r:id="R081a9ecfc79b44d9"/>
-    <p:sldId xmlns:r="http://schemas.openxmlformats.org/officeDocument/2006/relationships" id="257" r:id="Rf661df203b2d469e"/>
-    <p:sldId xmlns:r="http://schemas.openxmlformats.org/officeDocument/2006/relationships" id="258" r:id="R37f4029b17ae4559"/>
-    <p:sldId xmlns:r="http://schemas.openxmlformats.org/officeDocument/2006/relationships" id="259" r:id="R3ba7537ef0bd44b3"/>
-    <p:sldId xmlns:r="http://schemas.openxmlformats.org/officeDocument/2006/relationships" id="260" r:id="R8580c7eddc024747"/>
-    <p:sldId xmlns:r="http://schemas.openxmlformats.org/officeDocument/2006/relationships" id="261" r:id="Ra9078bbd18944f43"/>
-    <p:sldId xmlns:r="http://schemas.openxmlformats.org/officeDocument/2006/relationships" id="262" r:id="R1d682f5950eb4d88"/>
-    <p:sldId xmlns:r="http://schemas.openxmlformats.org/officeDocument/2006/relationships" id="263" r:id="R8504f4afb0be4ff6"/>
+    <p:sldId xmlns:r="http://schemas.openxmlformats.org/officeDocument/2006/relationships" id="256" r:id="R6eb6e1e3064a4c10"/>
+    <p:sldId xmlns:r="http://schemas.openxmlformats.org/officeDocument/2006/relationships" id="257" r:id="R44d9c46392f64179"/>
+    <p:sldId xmlns:r="http://schemas.openxmlformats.org/officeDocument/2006/relationships" id="258" r:id="R473ab0c0f76a45d2"/>
+    <p:sldId xmlns:r="http://schemas.openxmlformats.org/officeDocument/2006/relationships" id="259" r:id="Rfde98412f34b4e41"/>
+    <p:sldId xmlns:r="http://schemas.openxmlformats.org/officeDocument/2006/relationships" id="260" r:id="Rbc4118836e6f43d2"/>
+    <p:sldId xmlns:r="http://schemas.openxmlformats.org/officeDocument/2006/relationships" id="261" r:id="R136c6d22538948dd"/>
+    <p:sldId xmlns:r="http://schemas.openxmlformats.org/officeDocument/2006/relationships" id="262" r:id="R7a5ebdcf38b24460"/>
+    <p:sldId xmlns:r="http://schemas.openxmlformats.org/officeDocument/2006/relationships" id="263" r:id="R9cac1911f19d4420"/>
   </p:sldIdLst>
   <p:sldSz cx="12192000" cy="6858000"/>
   <p:notesSz cx="6858000" cy="9144000"/>
@@ -839,7 +839,7 @@
           </a:p>
           <a:p xmlns:a="http://schemas.openxmlformats.org/drawingml/2006/main">
             <a:r>
-              <a:t>The platform has automation beyond the inference endpoint. The fresh audit passed 112 CLI and 14 service tests. Terraform formatting and validation, chart render checks, and policy suites also passed. I found that the most recent remote CI run failed a new Checkov rule because the availability-zone lookup was unfiltered. The repair pins the zone identities and passes the local scan. The lesson is to verify the current pipeline rather than rely on an old green badge. Terraform validation is still distinct from proving a cloud apply.</a:t>
+              <a:t>The platform has automation beyond the inference endpoint. The fresh audit passed 112 CLI and 14 service tests. Terraform formatting and validation, chart render checks, and policy suites also passed. The audit reproduced an earlier pipeline failure caused by an unfiltered availability-zone lookup. The repair pins zone identities and passed 83 local Checkov checks. All seven GitHub CI jobs then passed on commit 111610a. The lesson is to verify the current pipeline rather than rely on an old badge. Terraform validation is still distinct from proving a cloud apply.</a:t>
             </a:r>
           </a:p>
           <a:p xmlns:a="http://schemas.openxmlformats.org/drawingml/2006/main">
@@ -854,7 +854,7 @@
           </a:p>
           <a:p xmlns:a="http://schemas.openxmlformats.org/drawingml/2006/main">
             <a:r>
-              <a:t>October 15 make check: 112 CLI + 14 service tests, six Terraform checks, chart checks and policy checks; Checkov reproduced CKV_AWS_394 then passed 83 checks after explicit zone-name filter. Latest inspected run https://github.com/johncobio/aiplatform/actions/runs/35232704084</a:t>
+              <a:t>October 15 make check: 112 CLI + 14 service tests, six Terraform checks, chart checks and policy checks; Checkov reproduced CKV_AWS_394 then passed 83 checks after explicit zone-name filter. Verified successful CI https://github.com/johncobio/aiplatform/actions/runs/38820810497</a:t>
             </a:r>
           </a:p>
         </p:txBody>
@@ -1186,7 +1186,7 @@
           <p:cNvPr id="3" name="Title">
             <a:extLst xmlns:a="http://schemas.openxmlformats.org/drawingml/2006/main">
               <a:ext uri="{FF2B5EF4-FFF2-40B4-BE49-F238E27FC236}">
-                <a16:creationId xmlns:a16="http://schemas.microsoft.com/office/drawing/2014/main" id="{7819A723-E34B-4493-ACFB-85A529793BEC}"/>
+                <a16:creationId xmlns:a16="http://schemas.microsoft.com/office/drawing/2014/main" id="{6ACB5573-E75E-4FEE-ABFE-C2C4A2A139D5}"/>
               </a:ext>
             </a:extLst>
           </p:cNvPr>
@@ -1343,7 +1343,7 @@
           <p:cNvPr id="2" name="Subtitle">
             <a:extLst xmlns:a="http://schemas.openxmlformats.org/drawingml/2006/main">
               <a:ext uri="{FF2B5EF4-FFF2-40B4-BE49-F238E27FC236}">
-                <a16:creationId xmlns:a16="http://schemas.microsoft.com/office/drawing/2014/main" id="{31837483-8C04-40EC-979E-BB5641B86C8A}"/>
+                <a16:creationId xmlns:a16="http://schemas.microsoft.com/office/drawing/2014/main" id="{A3A2143D-A57C-4589-9A65-11AB9833CFA1}"/>
               </a:ext>
             </a:extLst>
           </p:cNvPr>
@@ -1517,7 +1517,7 @@
           <p:cNvPr id="2" name="Section title">
             <a:extLst xmlns:a="http://schemas.openxmlformats.org/drawingml/2006/main">
               <a:ext uri="{FF2B5EF4-FFF2-40B4-BE49-F238E27FC236}">
-                <a16:creationId xmlns:a16="http://schemas.microsoft.com/office/drawing/2014/main" id="{34BCD7E9-6A46-4C73-BD09-8930CDFDF3DA}"/>
+                <a16:creationId xmlns:a16="http://schemas.microsoft.com/office/drawing/2014/main" id="{42553B61-5803-4CDD-AA69-6292FED744C0}"/>
               </a:ext>
             </a:extLst>
           </p:cNvPr>
@@ -1691,7 +1691,7 @@
           <p:cNvPr id="3" name="Title">
             <a:extLst xmlns:a="http://schemas.openxmlformats.org/drawingml/2006/main">
               <a:ext uri="{FF2B5EF4-FFF2-40B4-BE49-F238E27FC236}">
-                <a16:creationId xmlns:a16="http://schemas.microsoft.com/office/drawing/2014/main" id="{55DA91AB-CE2B-429D-BC4B-921CDAF3E79A}"/>
+                <a16:creationId xmlns:a16="http://schemas.microsoft.com/office/drawing/2014/main" id="{6A62E598-5287-475A-8B22-C2A63BA35BE4}"/>
               </a:ext>
             </a:extLst>
           </p:cNvPr>
@@ -1848,7 +1848,7 @@
           <p:cNvPr id="2" name="Body">
             <a:extLst xmlns:a="http://schemas.openxmlformats.org/drawingml/2006/main">
               <a:ext uri="{FF2B5EF4-FFF2-40B4-BE49-F238E27FC236}">
-                <a16:creationId xmlns:a16="http://schemas.microsoft.com/office/drawing/2014/main" id="{4EB92451-F5E1-46FE-BE4B-3E8750858AAC}"/>
+                <a16:creationId xmlns:a16="http://schemas.microsoft.com/office/drawing/2014/main" id="{C39EE02C-49CB-4CED-8B1C-9F1FFF1F85CC}"/>
               </a:ext>
             </a:extLst>
           </p:cNvPr>
@@ -2022,7 +2022,7 @@
           <p:cNvPr id="4" name="Title">
             <a:extLst xmlns:a="http://schemas.openxmlformats.org/drawingml/2006/main">
               <a:ext uri="{FF2B5EF4-FFF2-40B4-BE49-F238E27FC236}">
-                <a16:creationId xmlns:a16="http://schemas.microsoft.com/office/drawing/2014/main" id="{C2C7BF43-DCC8-47E3-BA89-7EF47844A584}"/>
+                <a16:creationId xmlns:a16="http://schemas.microsoft.com/office/drawing/2014/main" id="{C4F3BD03-3280-4563-A2BF-825ED1FCEE41}"/>
               </a:ext>
             </a:extLst>
           </p:cNvPr>
@@ -2179,7 +2179,7 @@
           <p:cNvPr id="2" name="Left column">
             <a:extLst xmlns:a="http://schemas.openxmlformats.org/drawingml/2006/main">
               <a:ext uri="{FF2B5EF4-FFF2-40B4-BE49-F238E27FC236}">
-                <a16:creationId xmlns:a16="http://schemas.microsoft.com/office/drawing/2014/main" id="{1D4D73DF-8C10-4F0C-9DA8-EC4774932C83}"/>
+                <a16:creationId xmlns:a16="http://schemas.microsoft.com/office/drawing/2014/main" id="{11D0A781-31DB-481F-85D8-23B67D67AE8A}"/>
               </a:ext>
             </a:extLst>
           </p:cNvPr>
@@ -2336,7 +2336,7 @@
           <p:cNvPr id="3" name="Right column">
             <a:extLst xmlns:a="http://schemas.openxmlformats.org/drawingml/2006/main">
               <a:ext uri="{FF2B5EF4-FFF2-40B4-BE49-F238E27FC236}">
-                <a16:creationId xmlns:a16="http://schemas.microsoft.com/office/drawing/2014/main" id="{3BD581D7-9148-49B3-87FC-4E74BC4D6E00}"/>
+                <a16:creationId xmlns:a16="http://schemas.microsoft.com/office/drawing/2014/main" id="{915EFEAF-0F8E-44DE-8E12-24A17948E7D7}"/>
               </a:ext>
             </a:extLst>
           </p:cNvPr>
@@ -2510,7 +2510,7 @@
           <p:cNvPr id="3" name="Title">
             <a:extLst xmlns:a="http://schemas.openxmlformats.org/drawingml/2006/main">
               <a:ext uri="{FF2B5EF4-FFF2-40B4-BE49-F238E27FC236}">
-                <a16:creationId xmlns:a16="http://schemas.microsoft.com/office/drawing/2014/main" id="{AFC7A6CE-19DE-41D0-9BE8-2B49B37E9227}"/>
+                <a16:creationId xmlns:a16="http://schemas.microsoft.com/office/drawing/2014/main" id="{6D4A70F3-8F12-40D2-B11B-4D349BF82E12}"/>
               </a:ext>
             </a:extLst>
           </p:cNvPr>
@@ -2667,7 +2667,7 @@
           <p:cNvPr id="2" name="Left column">
             <a:extLst xmlns:a="http://schemas.openxmlformats.org/drawingml/2006/main">
               <a:ext uri="{FF2B5EF4-FFF2-40B4-BE49-F238E27FC236}">
-                <a16:creationId xmlns:a16="http://schemas.microsoft.com/office/drawing/2014/main" id="{D27F775D-AB11-4940-ACB9-FCADC34BA092}"/>
+                <a16:creationId xmlns:a16="http://schemas.microsoft.com/office/drawing/2014/main" id="{3E59CB20-F865-40E3-B8DF-D8BDAB0034E9}"/>
               </a:ext>
             </a:extLst>
           </p:cNvPr>
@@ -2862,12 +2862,12 @@
   </p:cSld>
   <p:clrMap bg1="lt1" tx1="dk1" bg2="lt2" tx2="dk2" accent1="accent1" accent2="accent2" accent3="accent3" accent4="accent4" accent5="accent5" accent6="accent6" hlink="hlink" folHlink="folHlink"/>
   <p:sldLayoutIdLst>
-    <p:sldLayoutId xmlns:r="http://schemas.openxmlformats.org/officeDocument/2006/relationships" id="2147483649" r:id="Rf2034de594934cac"/>
-    <p:sldLayoutId xmlns:r="http://schemas.openxmlformats.org/officeDocument/2006/relationships" id="2147483650" r:id="Rd286546e8350490c"/>
-    <p:sldLayoutId xmlns:r="http://schemas.openxmlformats.org/officeDocument/2006/relationships" id="2147483651" r:id="Rc09775e50faf45af"/>
-    <p:sldLayoutId xmlns:r="http://schemas.openxmlformats.org/officeDocument/2006/relationships" id="2147483652" r:id="R0e8f867e76c348cf"/>
-    <p:sldLayoutId xmlns:r="http://schemas.openxmlformats.org/officeDocument/2006/relationships" id="2147483653" r:id="Rfa4507ea1f3d41d3"/>
-    <p:sldLayoutId xmlns:r="http://schemas.openxmlformats.org/officeDocument/2006/relationships" id="2147483654" r:id="R9b9e61ab40584695"/>
+    <p:sldLayoutId xmlns:r="http://schemas.openxmlformats.org/officeDocument/2006/relationships" id="2147483649" r:id="Rc10070be867247d6"/>
+    <p:sldLayoutId xmlns:r="http://schemas.openxmlformats.org/officeDocument/2006/relationships" id="2147483650" r:id="R68017a2dbae84baf"/>
+    <p:sldLayoutId xmlns:r="http://schemas.openxmlformats.org/officeDocument/2006/relationships" id="2147483651" r:id="Re9fa479c83bf4ab4"/>
+    <p:sldLayoutId xmlns:r="http://schemas.openxmlformats.org/officeDocument/2006/relationships" id="2147483652" r:id="Rb1c91bb68b97440d"/>
+    <p:sldLayoutId xmlns:r="http://schemas.openxmlformats.org/officeDocument/2006/relationships" id="2147483653" r:id="Re69df6139ada4bc7"/>
+    <p:sldLayoutId xmlns:r="http://schemas.openxmlformats.org/officeDocument/2006/relationships" id="2147483654" r:id="Rea30dcaf4f7a42eb"/>
   </p:sldLayoutIdLst>
   <p:txStyles>
     <p:titleStyle>
@@ -3578,7 +3578,7 @@
           <p:cNvPr id="6" name="">
             <a:extLst xmlns:a="http://schemas.openxmlformats.org/drawingml/2006/main">
               <a:ext uri="{FF2B5EF4-FFF2-40B4-BE49-F238E27FC236}">
-                <a16:creationId xmlns:a16="http://schemas.microsoft.com/office/drawing/2014/main" id="{7E3BEFDC-749A-4239-9C55-12FE49A207FF}"/>
+                <a16:creationId xmlns:a16="http://schemas.microsoft.com/office/drawing/2014/main" id="{79D8222A-9EB7-4D8A-9FA1-34FA68058D01}"/>
               </a:ext>
             </a:extLst>
           </p:cNvPr>
@@ -3646,7 +3646,7 @@
           <p:cNvPr id="2" name="">
             <a:extLst xmlns:a="http://schemas.openxmlformats.org/drawingml/2006/main">
               <a:ext uri="{FF2B5EF4-FFF2-40B4-BE49-F238E27FC236}">
-                <a16:creationId xmlns:a16="http://schemas.microsoft.com/office/drawing/2014/main" id="{6FC1BDDA-BEB8-46A7-8E63-EBA345309B7C}"/>
+                <a16:creationId xmlns:a16="http://schemas.microsoft.com/office/drawing/2014/main" id="{C61A5C2F-BFC5-4953-93DD-655D4C8D1F7E}"/>
               </a:ext>
             </a:extLst>
           </p:cNvPr>
@@ -3714,7 +3714,7 @@
           <p:cNvPr id="3" name="">
             <a:extLst xmlns:a="http://schemas.openxmlformats.org/drawingml/2006/main">
               <a:ext uri="{FF2B5EF4-FFF2-40B4-BE49-F238E27FC236}">
-                <a16:creationId xmlns:a16="http://schemas.microsoft.com/office/drawing/2014/main" id="{C3FF1326-0B7D-4AA8-BF2E-8FEE13FC3D9F}"/>
+                <a16:creationId xmlns:a16="http://schemas.microsoft.com/office/drawing/2014/main" id="{60FA9785-861F-461D-90EF-4848EF929122}"/>
               </a:ext>
             </a:extLst>
           </p:cNvPr>
@@ -3782,7 +3782,7 @@
           <p:cNvPr id="4" name="">
             <a:extLst xmlns:a="http://schemas.openxmlformats.org/drawingml/2006/main">
               <a:ext uri="{FF2B5EF4-FFF2-40B4-BE49-F238E27FC236}">
-                <a16:creationId xmlns:a16="http://schemas.microsoft.com/office/drawing/2014/main" id="{3D5B463A-1FD3-4C73-9A97-571F20E507F7}"/>
+                <a16:creationId xmlns:a16="http://schemas.microsoft.com/office/drawing/2014/main" id="{7541D08C-81EF-49FB-A22A-5735D1231294}"/>
               </a:ext>
             </a:extLst>
           </p:cNvPr>
@@ -3873,7 +3873,7 @@
           <p:cNvPr id="5" name="">
             <a:extLst xmlns:a="http://schemas.openxmlformats.org/drawingml/2006/main">
               <a:ext uri="{FF2B5EF4-FFF2-40B4-BE49-F238E27FC236}">
-                <a16:creationId xmlns:a16="http://schemas.microsoft.com/office/drawing/2014/main" id="{F6C48C97-74D8-418F-BDA5-A098524C1B5A}"/>
+                <a16:creationId xmlns:a16="http://schemas.microsoft.com/office/drawing/2014/main" id="{BBC2FED9-EE80-4BEC-AB5B-440779F8D498}"/>
               </a:ext>
             </a:extLst>
           </p:cNvPr>
@@ -3962,7 +3962,7 @@
     </p:spTree>
     <p:extLst>
       <p:ext uri="{BB962C8B-B14F-4D97-AF65-F5344CB8AC3E}">
-        <p14:creationId xmlns:p14="http://schemas.microsoft.com/office/powerpoint/2010/main" val="154797057"/>
+        <p14:creationId xmlns:p14="http://schemas.microsoft.com/office/powerpoint/2010/main" val="609398141"/>
       </p:ext>
     </p:extLst>
   </p:cSld>
@@ -3993,7 +3993,7 @@
           <p:cNvPr id="13" name="">
             <a:extLst xmlns:a="http://schemas.openxmlformats.org/drawingml/2006/main">
               <a:ext uri="{FF2B5EF4-FFF2-40B4-BE49-F238E27FC236}">
-                <a16:creationId xmlns:a16="http://schemas.microsoft.com/office/drawing/2014/main" id="{70845588-3337-47EA-9916-3969FF6AEEA8}"/>
+                <a16:creationId xmlns:a16="http://schemas.microsoft.com/office/drawing/2014/main" id="{1C544D8D-C7AB-4871-9512-75C272830BE1}"/>
               </a:ext>
             </a:extLst>
           </p:cNvPr>
@@ -4061,7 +4061,7 @@
           <p:cNvPr id="2" name="">
             <a:extLst xmlns:a="http://schemas.openxmlformats.org/drawingml/2006/main">
               <a:ext uri="{FF2B5EF4-FFF2-40B4-BE49-F238E27FC236}">
-                <a16:creationId xmlns:a16="http://schemas.microsoft.com/office/drawing/2014/main" id="{5C266BF5-F474-4100-87E2-9001FA92B581}"/>
+                <a16:creationId xmlns:a16="http://schemas.microsoft.com/office/drawing/2014/main" id="{099E42CC-FF15-42AA-B6E8-3254E88C9DCF}"/>
               </a:ext>
             </a:extLst>
           </p:cNvPr>
@@ -4129,7 +4129,7 @@
           <p:cNvPr id="3" name="">
             <a:extLst xmlns:a="http://schemas.openxmlformats.org/drawingml/2006/main">
               <a:ext uri="{FF2B5EF4-FFF2-40B4-BE49-F238E27FC236}">
-                <a16:creationId xmlns:a16="http://schemas.microsoft.com/office/drawing/2014/main" id="{BE18773A-D66F-4AE3-A6AB-C6BF55836E7A}"/>
+                <a16:creationId xmlns:a16="http://schemas.microsoft.com/office/drawing/2014/main" id="{1BD90414-CD8E-45C9-8E51-0F5BCE2AF8A1}"/>
               </a:ext>
             </a:extLst>
           </p:cNvPr>
@@ -4197,7 +4197,7 @@
           <p:cNvPr id="4" name="">
             <a:extLst xmlns:a="http://schemas.openxmlformats.org/drawingml/2006/main">
               <a:ext uri="{FF2B5EF4-FFF2-40B4-BE49-F238E27FC236}">
-                <a16:creationId xmlns:a16="http://schemas.microsoft.com/office/drawing/2014/main" id="{CA05FED1-850D-43E7-8DB0-1A66085233D9}"/>
+                <a16:creationId xmlns:a16="http://schemas.microsoft.com/office/drawing/2014/main" id="{696B21B6-0A75-4D72-8087-968FAF86A442}"/>
               </a:ext>
             </a:extLst>
           </p:cNvPr>
@@ -4265,7 +4265,7 @@
           <p:cNvPr id="5" name="">
             <a:extLst xmlns:a="http://schemas.openxmlformats.org/drawingml/2006/main">
               <a:ext uri="{FF2B5EF4-FFF2-40B4-BE49-F238E27FC236}">
-                <a16:creationId xmlns:a16="http://schemas.microsoft.com/office/drawing/2014/main" id="{DE63F610-AF89-46B8-86AA-3BDD8E37C171}"/>
+                <a16:creationId xmlns:a16="http://schemas.microsoft.com/office/drawing/2014/main" id="{03F77A2C-00AD-4196-97A8-FF2B49D34086}"/>
               </a:ext>
             </a:extLst>
           </p:cNvPr>
@@ -4333,7 +4333,7 @@
           <p:cNvPr id="6" name="">
             <a:extLst xmlns:a="http://schemas.openxmlformats.org/drawingml/2006/main">
               <a:ext uri="{FF2B5EF4-FFF2-40B4-BE49-F238E27FC236}">
-                <a16:creationId xmlns:a16="http://schemas.microsoft.com/office/drawing/2014/main" id="{DD38F1A6-18ED-42A2-B2C0-AEC4C57AC27D}"/>
+                <a16:creationId xmlns:a16="http://schemas.microsoft.com/office/drawing/2014/main" id="{6F98E2AD-911F-42DF-9A6B-34C7AE865BAD}"/>
               </a:ext>
             </a:extLst>
           </p:cNvPr>
@@ -4401,7 +4401,7 @@
           <p:cNvPr id="7" name="">
             <a:extLst xmlns:a="http://schemas.openxmlformats.org/drawingml/2006/main">
               <a:ext uri="{FF2B5EF4-FFF2-40B4-BE49-F238E27FC236}">
-                <a16:creationId xmlns:a16="http://schemas.microsoft.com/office/drawing/2014/main" id="{BD4C3444-5583-4767-B822-6D5D3DD53E09}"/>
+                <a16:creationId xmlns:a16="http://schemas.microsoft.com/office/drawing/2014/main" id="{44DEB960-32F4-4A04-BEC9-FC48548F163B}"/>
               </a:ext>
             </a:extLst>
           </p:cNvPr>
@@ -4469,7 +4469,7 @@
           <p:cNvPr id="8" name="">
             <a:extLst xmlns:a="http://schemas.openxmlformats.org/drawingml/2006/main">
               <a:ext uri="{FF2B5EF4-FFF2-40B4-BE49-F238E27FC236}">
-                <a16:creationId xmlns:a16="http://schemas.microsoft.com/office/drawing/2014/main" id="{FD4A2894-1F2C-4A46-AAAF-72A767FD87F1}"/>
+                <a16:creationId xmlns:a16="http://schemas.microsoft.com/office/drawing/2014/main" id="{E4DE9424-A662-4C21-BF5B-A6F0669E1EC6}"/>
               </a:ext>
             </a:extLst>
           </p:cNvPr>
@@ -4537,7 +4537,7 @@
           <p:cNvPr id="9" name="">
             <a:extLst xmlns:a="http://schemas.openxmlformats.org/drawingml/2006/main">
               <a:ext uri="{FF2B5EF4-FFF2-40B4-BE49-F238E27FC236}">
-                <a16:creationId xmlns:a16="http://schemas.microsoft.com/office/drawing/2014/main" id="{10C6A1DC-35A0-4ED8-91C1-697D199BF081}"/>
+                <a16:creationId xmlns:a16="http://schemas.microsoft.com/office/drawing/2014/main" id="{164A3B7A-F744-4321-A4CD-C5971F85FCAF}"/>
               </a:ext>
             </a:extLst>
           </p:cNvPr>
@@ -4569,7 +4569,7 @@
           <p:cNvPr id="10" name="">
             <a:extLst xmlns:a="http://schemas.openxmlformats.org/drawingml/2006/main">
               <a:ext uri="{FF2B5EF4-FFF2-40B4-BE49-F238E27FC236}">
-                <a16:creationId xmlns:a16="http://schemas.microsoft.com/office/drawing/2014/main" id="{425BCA47-67C4-412C-8D9C-F2BED9FC25E2}"/>
+                <a16:creationId xmlns:a16="http://schemas.microsoft.com/office/drawing/2014/main" id="{5FFF6A61-AB13-4C6E-A138-0629D3B79FE8}"/>
               </a:ext>
             </a:extLst>
           </p:cNvPr>
@@ -4637,7 +4637,7 @@
           <p:cNvPr id="11" name="">
             <a:extLst xmlns:a="http://schemas.openxmlformats.org/drawingml/2006/main">
               <a:ext uri="{FF2B5EF4-FFF2-40B4-BE49-F238E27FC236}">
-                <a16:creationId xmlns:a16="http://schemas.microsoft.com/office/drawing/2014/main" id="{AE02A119-FB87-47DD-B7B6-26ABF827533A}"/>
+                <a16:creationId xmlns:a16="http://schemas.microsoft.com/office/drawing/2014/main" id="{83ABA320-DF21-44A7-BC7F-F56490C97498}"/>
               </a:ext>
             </a:extLst>
           </p:cNvPr>
@@ -4820,7 +4820,7 @@
           <p:cNvPr id="12" name="">
             <a:extLst xmlns:a="http://schemas.openxmlformats.org/drawingml/2006/main">
               <a:ext uri="{FF2B5EF4-FFF2-40B4-BE49-F238E27FC236}">
-                <a16:creationId xmlns:a16="http://schemas.microsoft.com/office/drawing/2014/main" id="{9364252B-3455-4C5A-8A1B-D60F2F6E38D2}"/>
+                <a16:creationId xmlns:a16="http://schemas.microsoft.com/office/drawing/2014/main" id="{73E926DC-E1D6-45E7-B059-E0DD48FB89D8}"/>
               </a:ext>
             </a:extLst>
           </p:cNvPr>
@@ -4886,7 +4886,7 @@
     </p:spTree>
     <p:extLst>
       <p:ext uri="{BB962C8B-B14F-4D97-AF65-F5344CB8AC3E}">
-        <p14:creationId xmlns:p14="http://schemas.microsoft.com/office/powerpoint/2010/main" val="2103591267"/>
+        <p14:creationId xmlns:p14="http://schemas.microsoft.com/office/powerpoint/2010/main" val="646010709"/>
       </p:ext>
     </p:extLst>
   </p:cSld>
@@ -4917,7 +4917,7 @@
           <p:cNvPr id="27" name="">
             <a:extLst xmlns:a="http://schemas.openxmlformats.org/drawingml/2006/main">
               <a:ext uri="{FF2B5EF4-FFF2-40B4-BE49-F238E27FC236}">
-                <a16:creationId xmlns:a16="http://schemas.microsoft.com/office/drawing/2014/main" id="{E2218E64-5C01-4C24-97B3-5CF42046635E}"/>
+                <a16:creationId xmlns:a16="http://schemas.microsoft.com/office/drawing/2014/main" id="{F88255A4-3509-4209-9C7E-98D4F61E0536}"/>
               </a:ext>
             </a:extLst>
           </p:cNvPr>
@@ -4949,7 +4949,7 @@
           <p:cNvPr id="23" name="">
             <a:extLst xmlns:a="http://schemas.openxmlformats.org/drawingml/2006/main">
               <a:ext uri="{FF2B5EF4-FFF2-40B4-BE49-F238E27FC236}">
-                <a16:creationId xmlns:a16="http://schemas.microsoft.com/office/drawing/2014/main" id="{5F9D1ABD-D9C9-4AF4-895A-BBB661D84A98}"/>
+                <a16:creationId xmlns:a16="http://schemas.microsoft.com/office/drawing/2014/main" id="{E3859CAB-F33E-4357-9DDE-5817F8B2FD48}"/>
               </a:ext>
             </a:extLst>
           </p:cNvPr>
@@ -4981,7 +4981,7 @@
           <p:cNvPr id="22" name="">
             <a:extLst xmlns:a="http://schemas.openxmlformats.org/drawingml/2006/main">
               <a:ext uri="{FF2B5EF4-FFF2-40B4-BE49-F238E27FC236}">
-                <a16:creationId xmlns:a16="http://schemas.microsoft.com/office/drawing/2014/main" id="{CC7A3CA8-5D8B-435E-909D-D3CB8DE0ED78}"/>
+                <a16:creationId xmlns:a16="http://schemas.microsoft.com/office/drawing/2014/main" id="{99A7F26D-3855-4C48-8527-0B02A1538C35}"/>
               </a:ext>
             </a:extLst>
           </p:cNvPr>
@@ -5013,7 +5013,7 @@
           <p:cNvPr id="21" name="">
             <a:extLst xmlns:a="http://schemas.openxmlformats.org/drawingml/2006/main">
               <a:ext uri="{FF2B5EF4-FFF2-40B4-BE49-F238E27FC236}">
-                <a16:creationId xmlns:a16="http://schemas.microsoft.com/office/drawing/2014/main" id="{ED116755-E26F-4662-A5BC-26F4D18B7DC1}"/>
+                <a16:creationId xmlns:a16="http://schemas.microsoft.com/office/drawing/2014/main" id="{45A0CC0F-0C6F-455A-A93B-A4B191781777}"/>
               </a:ext>
             </a:extLst>
           </p:cNvPr>
@@ -5045,7 +5045,7 @@
           <p:cNvPr id="10" name="">
             <a:extLst xmlns:a="http://schemas.openxmlformats.org/drawingml/2006/main">
               <a:ext uri="{FF2B5EF4-FFF2-40B4-BE49-F238E27FC236}">
-                <a16:creationId xmlns:a16="http://schemas.microsoft.com/office/drawing/2014/main" id="{A7038FAB-2C73-4809-B7AC-1BDC4B7F1D88}"/>
+                <a16:creationId xmlns:a16="http://schemas.microsoft.com/office/drawing/2014/main" id="{53033880-7171-471B-A340-3D69F39DF4D2}"/>
               </a:ext>
             </a:extLst>
           </p:cNvPr>
@@ -5077,7 +5077,7 @@
           <p:cNvPr id="31" name="">
             <a:extLst xmlns:a="http://schemas.openxmlformats.org/drawingml/2006/main">
               <a:ext uri="{FF2B5EF4-FFF2-40B4-BE49-F238E27FC236}">
-                <a16:creationId xmlns:a16="http://schemas.microsoft.com/office/drawing/2014/main" id="{3FE3CB9E-7EB3-4C29-82E4-42E491BF3E4B}"/>
+                <a16:creationId xmlns:a16="http://schemas.microsoft.com/office/drawing/2014/main" id="{28A481A4-B37E-41DC-82BB-C000568E8E24}"/>
               </a:ext>
             </a:extLst>
           </p:cNvPr>
@@ -5145,7 +5145,7 @@
           <p:cNvPr id="2" name="">
             <a:extLst xmlns:a="http://schemas.openxmlformats.org/drawingml/2006/main">
               <a:ext uri="{FF2B5EF4-FFF2-40B4-BE49-F238E27FC236}">
-                <a16:creationId xmlns:a16="http://schemas.microsoft.com/office/drawing/2014/main" id="{6ACC6A47-BBD5-4099-A99E-A867DA166F84}"/>
+                <a16:creationId xmlns:a16="http://schemas.microsoft.com/office/drawing/2014/main" id="{0B5EEF8C-1BA3-4177-8616-27B3E6395B0E}"/>
               </a:ext>
             </a:extLst>
           </p:cNvPr>
@@ -5213,7 +5213,7 @@
           <p:cNvPr id="3" name="">
             <a:extLst xmlns:a="http://schemas.openxmlformats.org/drawingml/2006/main">
               <a:ext uri="{FF2B5EF4-FFF2-40B4-BE49-F238E27FC236}">
-                <a16:creationId xmlns:a16="http://schemas.microsoft.com/office/drawing/2014/main" id="{1AF85086-2990-481F-BBE2-9BE0E32A52C3}"/>
+                <a16:creationId xmlns:a16="http://schemas.microsoft.com/office/drawing/2014/main" id="{D2BB110E-ED13-4680-B149-510648B61F37}"/>
               </a:ext>
             </a:extLst>
           </p:cNvPr>
@@ -5281,7 +5281,7 @@
           <p:cNvPr id="4" name="">
             <a:extLst xmlns:a="http://schemas.openxmlformats.org/drawingml/2006/main">
               <a:ext uri="{FF2B5EF4-FFF2-40B4-BE49-F238E27FC236}">
-                <a16:creationId xmlns:a16="http://schemas.microsoft.com/office/drawing/2014/main" id="{CD0FE3AA-B9F4-4F70-A0A8-11DBAF492D8F}"/>
+                <a16:creationId xmlns:a16="http://schemas.microsoft.com/office/drawing/2014/main" id="{690F5046-AFED-4D1E-B07E-7C31582BE21E}"/>
               </a:ext>
             </a:extLst>
           </p:cNvPr>
@@ -5313,7 +5313,7 @@
           <p:cNvPr id="5" name="">
             <a:extLst xmlns:a="http://schemas.openxmlformats.org/drawingml/2006/main">
               <a:ext uri="{FF2B5EF4-FFF2-40B4-BE49-F238E27FC236}">
-                <a16:creationId xmlns:a16="http://schemas.microsoft.com/office/drawing/2014/main" id="{405ED184-73C7-43DE-9F35-6E2A9C2CE1C9}"/>
+                <a16:creationId xmlns:a16="http://schemas.microsoft.com/office/drawing/2014/main" id="{9D2E0049-82EF-40BA-929E-684CC4936D72}"/>
               </a:ext>
             </a:extLst>
           </p:cNvPr>
@@ -5381,7 +5381,7 @@
           <p:cNvPr id="6" name="">
             <a:extLst xmlns:a="http://schemas.openxmlformats.org/drawingml/2006/main">
               <a:ext uri="{FF2B5EF4-FFF2-40B4-BE49-F238E27FC236}">
-                <a16:creationId xmlns:a16="http://schemas.microsoft.com/office/drawing/2014/main" id="{FFE50B17-715D-469C-9B7A-5B59CCA7CC11}"/>
+                <a16:creationId xmlns:a16="http://schemas.microsoft.com/office/drawing/2014/main" id="{D2EC5ED8-DD7E-4064-94D1-90D66BA3AE37}"/>
               </a:ext>
             </a:extLst>
           </p:cNvPr>
@@ -5449,7 +5449,7 @@
           <p:cNvPr id="7" name="">
             <a:extLst xmlns:a="http://schemas.openxmlformats.org/drawingml/2006/main">
               <a:ext uri="{FF2B5EF4-FFF2-40B4-BE49-F238E27FC236}">
-                <a16:creationId xmlns:a16="http://schemas.microsoft.com/office/drawing/2014/main" id="{94C57403-1AEF-4D84-93E7-A10DE3FE568C}"/>
+                <a16:creationId xmlns:a16="http://schemas.microsoft.com/office/drawing/2014/main" id="{1909A785-6262-4506-A1E5-15715F86EC22}"/>
               </a:ext>
             </a:extLst>
           </p:cNvPr>
@@ -5481,7 +5481,7 @@
           <p:cNvPr id="8" name="">
             <a:extLst xmlns:a="http://schemas.openxmlformats.org/drawingml/2006/main">
               <a:ext uri="{FF2B5EF4-FFF2-40B4-BE49-F238E27FC236}">
-                <a16:creationId xmlns:a16="http://schemas.microsoft.com/office/drawing/2014/main" id="{57A027F2-B239-4F78-ACA1-56C2010AE49E}"/>
+                <a16:creationId xmlns:a16="http://schemas.microsoft.com/office/drawing/2014/main" id="{DA0B02D8-BB0A-4822-A33B-79002C375D17}"/>
               </a:ext>
             </a:extLst>
           </p:cNvPr>
@@ -5549,7 +5549,7 @@
           <p:cNvPr id="9" name="">
             <a:extLst xmlns:a="http://schemas.openxmlformats.org/drawingml/2006/main">
               <a:ext uri="{FF2B5EF4-FFF2-40B4-BE49-F238E27FC236}">
-                <a16:creationId xmlns:a16="http://schemas.microsoft.com/office/drawing/2014/main" id="{CFEB6B7C-B380-461B-A47E-580F64FA8087}"/>
+                <a16:creationId xmlns:a16="http://schemas.microsoft.com/office/drawing/2014/main" id="{363C9532-680A-4FFD-9C13-40489CA06B77}"/>
               </a:ext>
             </a:extLst>
           </p:cNvPr>
@@ -5617,7 +5617,7 @@
           <p:cNvPr id="11" name="">
             <a:extLst xmlns:a="http://schemas.openxmlformats.org/drawingml/2006/main">
               <a:ext uri="{FF2B5EF4-FFF2-40B4-BE49-F238E27FC236}">
-                <a16:creationId xmlns:a16="http://schemas.microsoft.com/office/drawing/2014/main" id="{46069222-455D-4F5B-8294-C5F0B4E797B0}"/>
+                <a16:creationId xmlns:a16="http://schemas.microsoft.com/office/drawing/2014/main" id="{635B2F98-9389-4BAF-AD4D-ADB2F9E3EB72}"/>
               </a:ext>
             </a:extLst>
           </p:cNvPr>
@@ -5685,7 +5685,7 @@
           <p:cNvPr id="12" name="">
             <a:extLst xmlns:a="http://schemas.openxmlformats.org/drawingml/2006/main">
               <a:ext uri="{FF2B5EF4-FFF2-40B4-BE49-F238E27FC236}">
-                <a16:creationId xmlns:a16="http://schemas.microsoft.com/office/drawing/2014/main" id="{A62C66FA-2CFF-43A8-8A7D-CEBB59764C32}"/>
+                <a16:creationId xmlns:a16="http://schemas.microsoft.com/office/drawing/2014/main" id="{48F77292-B0E3-47DB-BCCB-90923722007C}"/>
               </a:ext>
             </a:extLst>
           </p:cNvPr>
@@ -5717,7 +5717,7 @@
           <p:cNvPr id="13" name="">
             <a:extLst xmlns:a="http://schemas.openxmlformats.org/drawingml/2006/main">
               <a:ext uri="{FF2B5EF4-FFF2-40B4-BE49-F238E27FC236}">
-                <a16:creationId xmlns:a16="http://schemas.microsoft.com/office/drawing/2014/main" id="{2812D31E-DBAF-4ADB-8A14-8B55C10C8F8F}"/>
+                <a16:creationId xmlns:a16="http://schemas.microsoft.com/office/drawing/2014/main" id="{61D24C34-DA77-4CA4-9A89-96E02AEDEFCE}"/>
               </a:ext>
             </a:extLst>
           </p:cNvPr>
@@ -5785,7 +5785,7 @@
           <p:cNvPr id="14" name="">
             <a:extLst xmlns:a="http://schemas.openxmlformats.org/drawingml/2006/main">
               <a:ext uri="{FF2B5EF4-FFF2-40B4-BE49-F238E27FC236}">
-                <a16:creationId xmlns:a16="http://schemas.microsoft.com/office/drawing/2014/main" id="{7A89FEAC-539B-45A3-8441-E24CEB367B4F}"/>
+                <a16:creationId xmlns:a16="http://schemas.microsoft.com/office/drawing/2014/main" id="{FB23813F-26FB-46B2-9DAD-C574A0808857}"/>
               </a:ext>
             </a:extLst>
           </p:cNvPr>
@@ -5853,7 +5853,7 @@
           <p:cNvPr id="15" name="">
             <a:extLst xmlns:a="http://schemas.openxmlformats.org/drawingml/2006/main">
               <a:ext uri="{FF2B5EF4-FFF2-40B4-BE49-F238E27FC236}">
-                <a16:creationId xmlns:a16="http://schemas.microsoft.com/office/drawing/2014/main" id="{67C90B45-3A71-4F13-8294-B82031A347B0}"/>
+                <a16:creationId xmlns:a16="http://schemas.microsoft.com/office/drawing/2014/main" id="{9986A443-BC13-4E31-9E20-5FC78F37F0F3}"/>
               </a:ext>
             </a:extLst>
           </p:cNvPr>
@@ -5885,7 +5885,7 @@
           <p:cNvPr id="16" name="">
             <a:extLst xmlns:a="http://schemas.openxmlformats.org/drawingml/2006/main">
               <a:ext uri="{FF2B5EF4-FFF2-40B4-BE49-F238E27FC236}">
-                <a16:creationId xmlns:a16="http://schemas.microsoft.com/office/drawing/2014/main" id="{B671FA2E-4AFA-4A88-AC3A-8AC6A29E0870}"/>
+                <a16:creationId xmlns:a16="http://schemas.microsoft.com/office/drawing/2014/main" id="{3BAC924A-0D2C-493F-8D80-C0A85F8B1A8C}"/>
               </a:ext>
             </a:extLst>
           </p:cNvPr>
@@ -5953,7 +5953,7 @@
           <p:cNvPr id="17" name="">
             <a:extLst xmlns:a="http://schemas.openxmlformats.org/drawingml/2006/main">
               <a:ext uri="{FF2B5EF4-FFF2-40B4-BE49-F238E27FC236}">
-                <a16:creationId xmlns:a16="http://schemas.microsoft.com/office/drawing/2014/main" id="{26229905-5593-4D28-852E-C5914F4BE4B0}"/>
+                <a16:creationId xmlns:a16="http://schemas.microsoft.com/office/drawing/2014/main" id="{546DA14B-FA71-4E68-A33F-8AE4062A73BC}"/>
               </a:ext>
             </a:extLst>
           </p:cNvPr>
@@ -6021,7 +6021,7 @@
           <p:cNvPr id="18" name="">
             <a:extLst xmlns:a="http://schemas.openxmlformats.org/drawingml/2006/main">
               <a:ext uri="{FF2B5EF4-FFF2-40B4-BE49-F238E27FC236}">
-                <a16:creationId xmlns:a16="http://schemas.microsoft.com/office/drawing/2014/main" id="{FE8CC84D-3B96-4B40-9D24-089171149FC9}"/>
+                <a16:creationId xmlns:a16="http://schemas.microsoft.com/office/drawing/2014/main" id="{90774CD1-159D-47C6-BFB3-3FC6E2E59BDC}"/>
               </a:ext>
             </a:extLst>
           </p:cNvPr>
@@ -6053,7 +6053,7 @@
           <p:cNvPr id="19" name="">
             <a:extLst xmlns:a="http://schemas.openxmlformats.org/drawingml/2006/main">
               <a:ext uri="{FF2B5EF4-FFF2-40B4-BE49-F238E27FC236}">
-                <a16:creationId xmlns:a16="http://schemas.microsoft.com/office/drawing/2014/main" id="{DBABB63F-42BE-43AB-BDFA-D239447A5035}"/>
+                <a16:creationId xmlns:a16="http://schemas.microsoft.com/office/drawing/2014/main" id="{91C03C34-8B30-4BCA-9241-631DF29A49D8}"/>
               </a:ext>
             </a:extLst>
           </p:cNvPr>
@@ -6121,7 +6121,7 @@
           <p:cNvPr id="20" name="">
             <a:extLst xmlns:a="http://schemas.openxmlformats.org/drawingml/2006/main">
               <a:ext uri="{FF2B5EF4-FFF2-40B4-BE49-F238E27FC236}">
-                <a16:creationId xmlns:a16="http://schemas.microsoft.com/office/drawing/2014/main" id="{48A4E99B-B1DD-4099-8103-9EC90A59D5AE}"/>
+                <a16:creationId xmlns:a16="http://schemas.microsoft.com/office/drawing/2014/main" id="{2B404CD6-D322-439B-9AB6-476BBF44E1AE}"/>
               </a:ext>
             </a:extLst>
           </p:cNvPr>
@@ -6189,7 +6189,7 @@
           <p:cNvPr id="24" name="">
             <a:extLst xmlns:a="http://schemas.openxmlformats.org/drawingml/2006/main">
               <a:ext uri="{FF2B5EF4-FFF2-40B4-BE49-F238E27FC236}">
-                <a16:creationId xmlns:a16="http://schemas.microsoft.com/office/drawing/2014/main" id="{094D6BCE-E70B-4A0B-BAC1-CA3EA17CD133}"/>
+                <a16:creationId xmlns:a16="http://schemas.microsoft.com/office/drawing/2014/main" id="{7BE90C30-9578-4C24-8222-2C96147989C4}"/>
               </a:ext>
             </a:extLst>
           </p:cNvPr>
@@ -6221,7 +6221,7 @@
           <p:cNvPr id="25" name="">
             <a:extLst xmlns:a="http://schemas.openxmlformats.org/drawingml/2006/main">
               <a:ext uri="{FF2B5EF4-FFF2-40B4-BE49-F238E27FC236}">
-                <a16:creationId xmlns:a16="http://schemas.microsoft.com/office/drawing/2014/main" id="{4487C0C7-CB98-490A-A8F2-AD89B91071AF}"/>
+                <a16:creationId xmlns:a16="http://schemas.microsoft.com/office/drawing/2014/main" id="{A34D4A58-C587-4A47-A300-571605F9B57C}"/>
               </a:ext>
             </a:extLst>
           </p:cNvPr>
@@ -6289,7 +6289,7 @@
           <p:cNvPr id="26" name="">
             <a:extLst xmlns:a="http://schemas.openxmlformats.org/drawingml/2006/main">
               <a:ext uri="{FF2B5EF4-FFF2-40B4-BE49-F238E27FC236}">
-                <a16:creationId xmlns:a16="http://schemas.microsoft.com/office/drawing/2014/main" id="{9499E1E5-A60F-4323-81C6-0622C944FAB0}"/>
+                <a16:creationId xmlns:a16="http://schemas.microsoft.com/office/drawing/2014/main" id="{5E5F013D-085D-4AFB-A683-AC98E660E888}"/>
               </a:ext>
             </a:extLst>
           </p:cNvPr>
@@ -6357,7 +6357,7 @@
           <p:cNvPr id="28" name="">
             <a:extLst xmlns:a="http://schemas.openxmlformats.org/drawingml/2006/main">
               <a:ext uri="{FF2B5EF4-FFF2-40B4-BE49-F238E27FC236}">
-                <a16:creationId xmlns:a16="http://schemas.microsoft.com/office/drawing/2014/main" id="{8EC2AC68-0983-498C-B3B4-836582BE4AC8}"/>
+                <a16:creationId xmlns:a16="http://schemas.microsoft.com/office/drawing/2014/main" id="{EBDE3F11-4E17-488C-B49E-30639105721C}"/>
               </a:ext>
             </a:extLst>
           </p:cNvPr>
@@ -6425,7 +6425,7 @@
           <p:cNvPr id="29" name="">
             <a:extLst xmlns:a="http://schemas.openxmlformats.org/drawingml/2006/main">
               <a:ext uri="{FF2B5EF4-FFF2-40B4-BE49-F238E27FC236}">
-                <a16:creationId xmlns:a16="http://schemas.microsoft.com/office/drawing/2014/main" id="{165443D0-5A77-4435-BD09-934EE856D03F}"/>
+                <a16:creationId xmlns:a16="http://schemas.microsoft.com/office/drawing/2014/main" id="{38932564-11FE-49AB-B403-10171876C224}"/>
               </a:ext>
             </a:extLst>
           </p:cNvPr>
@@ -6493,7 +6493,7 @@
           <p:cNvPr id="30" name="">
             <a:extLst xmlns:a="http://schemas.openxmlformats.org/drawingml/2006/main">
               <a:ext uri="{FF2B5EF4-FFF2-40B4-BE49-F238E27FC236}">
-                <a16:creationId xmlns:a16="http://schemas.microsoft.com/office/drawing/2014/main" id="{F6DB70A5-C4EA-4DBD-AD61-E5639EC8D69F}"/>
+                <a16:creationId xmlns:a16="http://schemas.microsoft.com/office/drawing/2014/main" id="{27154CBD-7941-44AA-A468-D371EE03DCEC}"/>
               </a:ext>
             </a:extLst>
           </p:cNvPr>
@@ -6559,7 +6559,7 @@
     </p:spTree>
     <p:extLst>
       <p:ext uri="{BB962C8B-B14F-4D97-AF65-F5344CB8AC3E}">
-        <p14:creationId xmlns:p14="http://schemas.microsoft.com/office/powerpoint/2010/main" val="112841701"/>
+        <p14:creationId xmlns:p14="http://schemas.microsoft.com/office/powerpoint/2010/main" val="1040077181"/>
       </p:ext>
     </p:extLst>
   </p:cSld>
@@ -6590,7 +6590,7 @@
           <p:cNvPr id="14" name="">
             <a:extLst xmlns:a="http://schemas.openxmlformats.org/drawingml/2006/main">
               <a:ext uri="{FF2B5EF4-FFF2-40B4-BE49-F238E27FC236}">
-                <a16:creationId xmlns:a16="http://schemas.microsoft.com/office/drawing/2014/main" id="{3CCD867F-4E72-48DD-B772-408CB7563610}"/>
+                <a16:creationId xmlns:a16="http://schemas.microsoft.com/office/drawing/2014/main" id="{87882B01-7B23-45D3-8A02-D8C55971E648}"/>
               </a:ext>
             </a:extLst>
           </p:cNvPr>
@@ -6622,7 +6622,7 @@
           <p:cNvPr id="13" name="">
             <a:extLst xmlns:a="http://schemas.openxmlformats.org/drawingml/2006/main">
               <a:ext uri="{FF2B5EF4-FFF2-40B4-BE49-F238E27FC236}">
-                <a16:creationId xmlns:a16="http://schemas.microsoft.com/office/drawing/2014/main" id="{CED9791D-0019-421B-8B5C-F0E5CDE7A0BC}"/>
+                <a16:creationId xmlns:a16="http://schemas.microsoft.com/office/drawing/2014/main" id="{0C9278CF-8002-49F2-8208-F0C59AD0D1EC}"/>
               </a:ext>
             </a:extLst>
           </p:cNvPr>
@@ -6654,7 +6654,7 @@
           <p:cNvPr id="18" name="">
             <a:extLst xmlns:a="http://schemas.openxmlformats.org/drawingml/2006/main">
               <a:ext uri="{FF2B5EF4-FFF2-40B4-BE49-F238E27FC236}">
-                <a16:creationId xmlns:a16="http://schemas.microsoft.com/office/drawing/2014/main" id="{94CE745A-C0D1-44FF-A09C-FB728C4BA101}"/>
+                <a16:creationId xmlns:a16="http://schemas.microsoft.com/office/drawing/2014/main" id="{7E04CEEE-C942-4F48-BE40-846EFFCB4412}"/>
               </a:ext>
             </a:extLst>
           </p:cNvPr>
@@ -6722,7 +6722,7 @@
           <p:cNvPr id="2" name="">
             <a:extLst xmlns:a="http://schemas.openxmlformats.org/drawingml/2006/main">
               <a:ext uri="{FF2B5EF4-FFF2-40B4-BE49-F238E27FC236}">
-                <a16:creationId xmlns:a16="http://schemas.microsoft.com/office/drawing/2014/main" id="{3161D239-A9B6-4ABD-9A59-4F2E469FA914}"/>
+                <a16:creationId xmlns:a16="http://schemas.microsoft.com/office/drawing/2014/main" id="{5BCDE387-82BD-4EDD-B93E-F5D571AABA73}"/>
               </a:ext>
             </a:extLst>
           </p:cNvPr>
@@ -6790,7 +6790,7 @@
           <p:cNvPr id="3" name="">
             <a:extLst xmlns:a="http://schemas.openxmlformats.org/drawingml/2006/main">
               <a:ext uri="{FF2B5EF4-FFF2-40B4-BE49-F238E27FC236}">
-                <a16:creationId xmlns:a16="http://schemas.microsoft.com/office/drawing/2014/main" id="{538343C6-46DC-4B78-BB2C-B92A482FD846}"/>
+                <a16:creationId xmlns:a16="http://schemas.microsoft.com/office/drawing/2014/main" id="{4016ED34-1E3A-4BAF-8C8E-D0E685967BB1}"/>
               </a:ext>
             </a:extLst>
           </p:cNvPr>
@@ -6858,7 +6858,7 @@
           <p:cNvPr id="4" name="">
             <a:extLst xmlns:a="http://schemas.openxmlformats.org/drawingml/2006/main">
               <a:ext uri="{FF2B5EF4-FFF2-40B4-BE49-F238E27FC236}">
-                <a16:creationId xmlns:a16="http://schemas.microsoft.com/office/drawing/2014/main" id="{460846F9-75EE-46FA-956C-748C21BD2DC1}"/>
+                <a16:creationId xmlns:a16="http://schemas.microsoft.com/office/drawing/2014/main" id="{D65173D0-210C-4EDB-A61E-5614F023B001}"/>
               </a:ext>
             </a:extLst>
           </p:cNvPr>
@@ -6890,7 +6890,7 @@
           <p:cNvPr id="5" name="">
             <a:extLst xmlns:a="http://schemas.openxmlformats.org/drawingml/2006/main">
               <a:ext uri="{FF2B5EF4-FFF2-40B4-BE49-F238E27FC236}">
-                <a16:creationId xmlns:a16="http://schemas.microsoft.com/office/drawing/2014/main" id="{EEB87117-B96E-4802-A6A9-4533D964EFE4}"/>
+                <a16:creationId xmlns:a16="http://schemas.microsoft.com/office/drawing/2014/main" id="{0920F1FE-0496-4F7E-BCBE-18CFB9B8C4F8}"/>
               </a:ext>
             </a:extLst>
           </p:cNvPr>
@@ -6958,7 +6958,7 @@
           <p:cNvPr id="6" name="">
             <a:extLst xmlns:a="http://schemas.openxmlformats.org/drawingml/2006/main">
               <a:ext uri="{FF2B5EF4-FFF2-40B4-BE49-F238E27FC236}">
-                <a16:creationId xmlns:a16="http://schemas.microsoft.com/office/drawing/2014/main" id="{26679955-7B4D-4179-BE80-D506EE4FC86D}"/>
+                <a16:creationId xmlns:a16="http://schemas.microsoft.com/office/drawing/2014/main" id="{7FF9EDC5-1C2F-4C01-A4A3-0FBB41E90F92}"/>
               </a:ext>
             </a:extLst>
           </p:cNvPr>
@@ -7026,7 +7026,7 @@
           <p:cNvPr id="7" name="">
             <a:extLst xmlns:a="http://schemas.openxmlformats.org/drawingml/2006/main">
               <a:ext uri="{FF2B5EF4-FFF2-40B4-BE49-F238E27FC236}">
-                <a16:creationId xmlns:a16="http://schemas.microsoft.com/office/drawing/2014/main" id="{3307C32E-371C-4900-8ADF-B962557D5EC6}"/>
+                <a16:creationId xmlns:a16="http://schemas.microsoft.com/office/drawing/2014/main" id="{E912216C-4E2D-4A3A-BE62-35DE7D502C64}"/>
               </a:ext>
             </a:extLst>
           </p:cNvPr>
@@ -7058,7 +7058,7 @@
           <p:cNvPr id="8" name="">
             <a:extLst xmlns:a="http://schemas.openxmlformats.org/drawingml/2006/main">
               <a:ext uri="{FF2B5EF4-FFF2-40B4-BE49-F238E27FC236}">
-                <a16:creationId xmlns:a16="http://schemas.microsoft.com/office/drawing/2014/main" id="{775510B7-E7DE-4457-BFB2-FD75021A9E65}"/>
+                <a16:creationId xmlns:a16="http://schemas.microsoft.com/office/drawing/2014/main" id="{94A287A4-F634-4891-BB79-E8A00316C8AB}"/>
               </a:ext>
             </a:extLst>
           </p:cNvPr>
@@ -7126,7 +7126,7 @@
           <p:cNvPr id="9" name="">
             <a:extLst xmlns:a="http://schemas.openxmlformats.org/drawingml/2006/main">
               <a:ext uri="{FF2B5EF4-FFF2-40B4-BE49-F238E27FC236}">
-                <a16:creationId xmlns:a16="http://schemas.microsoft.com/office/drawing/2014/main" id="{173C3AFF-DEA0-4450-9ADE-9698CB2D6E12}"/>
+                <a16:creationId xmlns:a16="http://schemas.microsoft.com/office/drawing/2014/main" id="{01D8545A-1BA2-4643-B084-F440883F2CCB}"/>
               </a:ext>
             </a:extLst>
           </p:cNvPr>
@@ -7194,7 +7194,7 @@
           <p:cNvPr id="10" name="">
             <a:extLst xmlns:a="http://schemas.openxmlformats.org/drawingml/2006/main">
               <a:ext uri="{FF2B5EF4-FFF2-40B4-BE49-F238E27FC236}">
-                <a16:creationId xmlns:a16="http://schemas.microsoft.com/office/drawing/2014/main" id="{7EFC14B3-006A-4D6C-BD33-01708DEDC08C}"/>
+                <a16:creationId xmlns:a16="http://schemas.microsoft.com/office/drawing/2014/main" id="{E137A82C-CBB9-4776-B2ED-0FBD6805359F}"/>
               </a:ext>
             </a:extLst>
           </p:cNvPr>
@@ -7226,7 +7226,7 @@
           <p:cNvPr id="11" name="">
             <a:extLst xmlns:a="http://schemas.openxmlformats.org/drawingml/2006/main">
               <a:ext uri="{FF2B5EF4-FFF2-40B4-BE49-F238E27FC236}">
-                <a16:creationId xmlns:a16="http://schemas.microsoft.com/office/drawing/2014/main" id="{9C40CB1D-B13E-429B-A238-74790C7F436D}"/>
+                <a16:creationId xmlns:a16="http://schemas.microsoft.com/office/drawing/2014/main" id="{D90BD839-C5A7-466E-98CA-BD79A2176934}"/>
               </a:ext>
             </a:extLst>
           </p:cNvPr>
@@ -7294,7 +7294,7 @@
           <p:cNvPr id="12" name="">
             <a:extLst xmlns:a="http://schemas.openxmlformats.org/drawingml/2006/main">
               <a:ext uri="{FF2B5EF4-FFF2-40B4-BE49-F238E27FC236}">
-                <a16:creationId xmlns:a16="http://schemas.microsoft.com/office/drawing/2014/main" id="{DFEE3D2D-FDAF-431D-9538-2350A98FC6F3}"/>
+                <a16:creationId xmlns:a16="http://schemas.microsoft.com/office/drawing/2014/main" id="{A0259F39-527B-4ED9-9DC9-4BAFD1B88B8D}"/>
               </a:ext>
             </a:extLst>
           </p:cNvPr>
@@ -7362,7 +7362,7 @@
           <p:cNvPr id="15" name="">
             <a:extLst xmlns:a="http://schemas.openxmlformats.org/drawingml/2006/main">
               <a:ext uri="{FF2B5EF4-FFF2-40B4-BE49-F238E27FC236}">
-                <a16:creationId xmlns:a16="http://schemas.microsoft.com/office/drawing/2014/main" id="{29E6899B-3A6B-4500-89AC-E9D05AAC0610}"/>
+                <a16:creationId xmlns:a16="http://schemas.microsoft.com/office/drawing/2014/main" id="{E6112873-4715-4C61-A341-0ABED82F7041}"/>
               </a:ext>
             </a:extLst>
           </p:cNvPr>
@@ -7430,7 +7430,7 @@
           <p:cNvPr id="16" name="">
             <a:extLst xmlns:a="http://schemas.openxmlformats.org/drawingml/2006/main">
               <a:ext uri="{FF2B5EF4-FFF2-40B4-BE49-F238E27FC236}">
-                <a16:creationId xmlns:a16="http://schemas.microsoft.com/office/drawing/2014/main" id="{D3312822-30EA-4BDA-A4DF-86EDB872AFD3}"/>
+                <a16:creationId xmlns:a16="http://schemas.microsoft.com/office/drawing/2014/main" id="{D8F7BF60-C5FA-44DB-AD93-2BAD52B45845}"/>
               </a:ext>
             </a:extLst>
           </p:cNvPr>
@@ -7521,7 +7521,7 @@
           <p:cNvPr id="17" name="">
             <a:extLst xmlns:a="http://schemas.openxmlformats.org/drawingml/2006/main">
               <a:ext uri="{FF2B5EF4-FFF2-40B4-BE49-F238E27FC236}">
-                <a16:creationId xmlns:a16="http://schemas.microsoft.com/office/drawing/2014/main" id="{2ED35E62-4374-4AEB-A833-A0C0B75188DF}"/>
+                <a16:creationId xmlns:a16="http://schemas.microsoft.com/office/drawing/2014/main" id="{4AF9B85A-40BE-4506-9CE5-676B29C07EC0}"/>
               </a:ext>
             </a:extLst>
           </p:cNvPr>
@@ -7587,7 +7587,7 @@
     </p:spTree>
     <p:extLst>
       <p:ext uri="{BB962C8B-B14F-4D97-AF65-F5344CB8AC3E}">
-        <p14:creationId xmlns:p14="http://schemas.microsoft.com/office/powerpoint/2010/main" val="1559152461"/>
+        <p14:creationId xmlns:p14="http://schemas.microsoft.com/office/powerpoint/2010/main" val="996138815"/>
       </p:ext>
     </p:extLst>
   </p:cSld>
@@ -7618,7 +7618,7 @@
           <p:cNvPr id="13" name="">
             <a:extLst xmlns:a="http://schemas.openxmlformats.org/drawingml/2006/main">
               <a:ext uri="{FF2B5EF4-FFF2-40B4-BE49-F238E27FC236}">
-                <a16:creationId xmlns:a16="http://schemas.microsoft.com/office/drawing/2014/main" id="{4C9D3F2A-7441-47CD-8818-138F9E6A05F7}"/>
+                <a16:creationId xmlns:a16="http://schemas.microsoft.com/office/drawing/2014/main" id="{08161AAE-128A-4F09-A945-E81B7D242FEA}"/>
               </a:ext>
             </a:extLst>
           </p:cNvPr>
@@ -7686,7 +7686,7 @@
           <p:cNvPr id="2" name="">
             <a:extLst xmlns:a="http://schemas.openxmlformats.org/drawingml/2006/main">
               <a:ext uri="{FF2B5EF4-FFF2-40B4-BE49-F238E27FC236}">
-                <a16:creationId xmlns:a16="http://schemas.microsoft.com/office/drawing/2014/main" id="{65425C85-6657-4F15-BDEA-9109B682B19B}"/>
+                <a16:creationId xmlns:a16="http://schemas.microsoft.com/office/drawing/2014/main" id="{EE548FE6-98B6-4F56-9878-2F024FB99AEF}"/>
               </a:ext>
             </a:extLst>
           </p:cNvPr>
@@ -7754,7 +7754,7 @@
           <p:cNvPr id="3" name="">
             <a:extLst xmlns:a="http://schemas.openxmlformats.org/drawingml/2006/main">
               <a:ext uri="{FF2B5EF4-FFF2-40B4-BE49-F238E27FC236}">
-                <a16:creationId xmlns:a16="http://schemas.microsoft.com/office/drawing/2014/main" id="{2D532E53-B5C6-491F-8A27-295630F6C5F3}"/>
+                <a16:creationId xmlns:a16="http://schemas.microsoft.com/office/drawing/2014/main" id="{099ED046-4C8E-4862-8CD2-D04D7271470F}"/>
               </a:ext>
             </a:extLst>
           </p:cNvPr>
@@ -7822,7 +7822,7 @@
           <p:cNvPr id="4" name="">
             <a:extLst xmlns:a="http://schemas.openxmlformats.org/drawingml/2006/main">
               <a:ext uri="{FF2B5EF4-FFF2-40B4-BE49-F238E27FC236}">
-                <a16:creationId xmlns:a16="http://schemas.microsoft.com/office/drawing/2014/main" id="{910F545F-6AF0-48C7-86DF-8566BAF9E98F}"/>
+                <a16:creationId xmlns:a16="http://schemas.microsoft.com/office/drawing/2014/main" id="{A21C3716-FD98-42BC-A204-12673A1F661E}"/>
               </a:ext>
             </a:extLst>
           </p:cNvPr>
@@ -7890,7 +7890,7 @@
           <p:cNvPr id="5" name="">
             <a:extLst xmlns:a="http://schemas.openxmlformats.org/drawingml/2006/main">
               <a:ext uri="{FF2B5EF4-FFF2-40B4-BE49-F238E27FC236}">
-                <a16:creationId xmlns:a16="http://schemas.microsoft.com/office/drawing/2014/main" id="{0A6C409B-D2F3-4F3F-B3AC-1E7A41C18928}"/>
+                <a16:creationId xmlns:a16="http://schemas.microsoft.com/office/drawing/2014/main" id="{3A2744ED-9E0B-4E8D-9F4A-8E2356E83D78}"/>
               </a:ext>
             </a:extLst>
           </p:cNvPr>
@@ -7958,7 +7958,7 @@
           <p:cNvPr id="6" name="">
             <a:extLst xmlns:a="http://schemas.openxmlformats.org/drawingml/2006/main">
               <a:ext uri="{FF2B5EF4-FFF2-40B4-BE49-F238E27FC236}">
-                <a16:creationId xmlns:a16="http://schemas.microsoft.com/office/drawing/2014/main" id="{D42032A4-5A4A-4731-A32B-4F6CAAEFD647}"/>
+                <a16:creationId xmlns:a16="http://schemas.microsoft.com/office/drawing/2014/main" id="{DEF50002-1572-4F23-8A2E-5B6A0A4E20AA}"/>
               </a:ext>
             </a:extLst>
           </p:cNvPr>
@@ -8026,7 +8026,7 @@
           <p:cNvPr id="7" name="">
             <a:extLst xmlns:a="http://schemas.openxmlformats.org/drawingml/2006/main">
               <a:ext uri="{FF2B5EF4-FFF2-40B4-BE49-F238E27FC236}">
-                <a16:creationId xmlns:a16="http://schemas.microsoft.com/office/drawing/2014/main" id="{93300915-2B64-41F1-8F9E-2D0AF5990B63}"/>
+                <a16:creationId xmlns:a16="http://schemas.microsoft.com/office/drawing/2014/main" id="{1D83F6FC-E8D6-4892-B1D6-4C8FFEA61E6B}"/>
               </a:ext>
             </a:extLst>
           </p:cNvPr>
@@ -8094,7 +8094,7 @@
           <p:cNvPr id="8" name="">
             <a:extLst xmlns:a="http://schemas.openxmlformats.org/drawingml/2006/main">
               <a:ext uri="{FF2B5EF4-FFF2-40B4-BE49-F238E27FC236}">
-                <a16:creationId xmlns:a16="http://schemas.microsoft.com/office/drawing/2014/main" id="{4E5C0442-117E-4843-A593-B30D61DC3B68}"/>
+                <a16:creationId xmlns:a16="http://schemas.microsoft.com/office/drawing/2014/main" id="{8993454E-FD0A-4689-9241-4AAF93503428}"/>
               </a:ext>
             </a:extLst>
           </p:cNvPr>
@@ -8162,7 +8162,7 @@
           <p:cNvPr id="9" name="">
             <a:extLst xmlns:a="http://schemas.openxmlformats.org/drawingml/2006/main">
               <a:ext uri="{FF2B5EF4-FFF2-40B4-BE49-F238E27FC236}">
-                <a16:creationId xmlns:a16="http://schemas.microsoft.com/office/drawing/2014/main" id="{328EA92A-D9A0-483F-9BAF-6F275426853C}"/>
+                <a16:creationId xmlns:a16="http://schemas.microsoft.com/office/drawing/2014/main" id="{CFCF466B-2EB5-4372-8345-5341F626EE86}"/>
               </a:ext>
             </a:extLst>
           </p:cNvPr>
@@ -8230,7 +8230,7 @@
           <p:cNvPr id="10" name="">
             <a:extLst xmlns:a="http://schemas.openxmlformats.org/drawingml/2006/main">
               <a:ext uri="{FF2B5EF4-FFF2-40B4-BE49-F238E27FC236}">
-                <a16:creationId xmlns:a16="http://schemas.microsoft.com/office/drawing/2014/main" id="{42F82A9B-CA3E-4DF7-962B-62C00132CEF1}"/>
+                <a16:creationId xmlns:a16="http://schemas.microsoft.com/office/drawing/2014/main" id="{4DA86E36-E734-489E-B883-30688DE1224E}"/>
               </a:ext>
             </a:extLst>
           </p:cNvPr>
@@ -8298,7 +8298,7 @@
           <p:cNvPr id="11" name="">
             <a:extLst xmlns:a="http://schemas.openxmlformats.org/drawingml/2006/main">
               <a:ext uri="{FF2B5EF4-FFF2-40B4-BE49-F238E27FC236}">
-                <a16:creationId xmlns:a16="http://schemas.microsoft.com/office/drawing/2014/main" id="{C086A82E-1A12-414D-BB4D-3BF3DBF94B49}"/>
+                <a16:creationId xmlns:a16="http://schemas.microsoft.com/office/drawing/2014/main" id="{B7300B51-6D25-429E-9F56-E43876569F46}"/>
               </a:ext>
             </a:extLst>
           </p:cNvPr>
@@ -8366,7 +8366,7 @@
           <p:cNvPr id="12" name="">
             <a:extLst xmlns:a="http://schemas.openxmlformats.org/drawingml/2006/main">
               <a:ext uri="{FF2B5EF4-FFF2-40B4-BE49-F238E27FC236}">
-                <a16:creationId xmlns:a16="http://schemas.microsoft.com/office/drawing/2014/main" id="{6785754E-4FBD-4529-AEF5-DB5D66AE3CFC}"/>
+                <a16:creationId xmlns:a16="http://schemas.microsoft.com/office/drawing/2014/main" id="{C589F586-EB03-4CD6-9778-691D79782623}"/>
               </a:ext>
             </a:extLst>
           </p:cNvPr>
@@ -8396,7 +8396,7 @@
             <a:defPPr>
               <a:defRPr sz="1575" b="0">
                 <a:solidFill>
-                  <a:srgbClr val="B6601E"/>
+                  <a:srgbClr val="087E70"/>
                 </a:solidFill>
                 <a:latin typeface="Arial"/>
                 <a:ea typeface="Arial"/>
@@ -8408,7 +8408,7 @@
             <a:pPr>
               <a:defRPr sz="1575" b="0">
                 <a:solidFill>
-                  <a:srgbClr val="B6601E"/>
+                  <a:srgbClr val="087E70"/>
                 </a:solidFill>
                 <a:latin typeface="Arial"/>
                 <a:ea typeface="Arial"/>
@@ -8418,13 +8418,13 @@
             <a:r>
               <a:rPr sz="1575" b="0">
                 <a:solidFill>
-                  <a:srgbClr val="B6601E"/>
+                  <a:srgbClr val="087E70"/>
                 </a:solidFill>
                 <a:latin typeface="Arial"/>
                 <a:ea typeface="Arial"/>
                 <a:cs typeface="Arial"/>
               </a:rPr>
-              <a:t>Fresh local checks pass. Remote CI needs rechecking after the zone-selection repair.</a:t>
+              <a:t>Local checks and all seven CI jobs passed after the zone-selection repair.</a:t>
             </a:r>
           </a:p>
         </p:txBody>
@@ -8432,7 +8432,7 @@
     </p:spTree>
     <p:extLst>
       <p:ext uri="{BB962C8B-B14F-4D97-AF65-F5344CB8AC3E}">
-        <p14:creationId xmlns:p14="http://schemas.microsoft.com/office/powerpoint/2010/main" val="1297145901"/>
+        <p14:creationId xmlns:p14="http://schemas.microsoft.com/office/powerpoint/2010/main" val="890663015"/>
       </p:ext>
     </p:extLst>
   </p:cSld>
@@ -8463,7 +8463,7 @@
           <p:cNvPr id="11" name="">
             <a:extLst xmlns:a="http://schemas.openxmlformats.org/drawingml/2006/main">
               <a:ext uri="{FF2B5EF4-FFF2-40B4-BE49-F238E27FC236}">
-                <a16:creationId xmlns:a16="http://schemas.microsoft.com/office/drawing/2014/main" id="{2B2A94B7-6258-4B6C-8CC7-DB5EE3356454}"/>
+                <a16:creationId xmlns:a16="http://schemas.microsoft.com/office/drawing/2014/main" id="{5B5A255A-9A3D-4553-8385-D8BCD0F9F073}"/>
               </a:ext>
             </a:extLst>
           </p:cNvPr>
@@ -8531,7 +8531,7 @@
           <p:cNvPr id="2" name="">
             <a:extLst xmlns:a="http://schemas.openxmlformats.org/drawingml/2006/main">
               <a:ext uri="{FF2B5EF4-FFF2-40B4-BE49-F238E27FC236}">
-                <a16:creationId xmlns:a16="http://schemas.microsoft.com/office/drawing/2014/main" id="{B24936D4-972F-45B9-AB9F-05AC19B4EBFC}"/>
+                <a16:creationId xmlns:a16="http://schemas.microsoft.com/office/drawing/2014/main" id="{612B5DD8-F2B1-46AF-A909-79F8A2DC6959}"/>
               </a:ext>
             </a:extLst>
           </p:cNvPr>
@@ -8599,7 +8599,7 @@
           <p:cNvPr id="3" name="">
             <a:extLst xmlns:a="http://schemas.openxmlformats.org/drawingml/2006/main">
               <a:ext uri="{FF2B5EF4-FFF2-40B4-BE49-F238E27FC236}">
-                <a16:creationId xmlns:a16="http://schemas.microsoft.com/office/drawing/2014/main" id="{111E089B-7176-4EF1-A3E9-16A0D6D7324A}"/>
+                <a16:creationId xmlns:a16="http://schemas.microsoft.com/office/drawing/2014/main" id="{7D5DB897-7221-4BB1-B177-97463EE38430}"/>
               </a:ext>
             </a:extLst>
           </p:cNvPr>
@@ -8667,7 +8667,7 @@
           <p:cNvPr id="4" name="Chart">
             <a:extLst xmlns:a="http://schemas.openxmlformats.org/drawingml/2006/main">
               <a:ext uri="{FF2B5EF4-FFF2-40B4-BE49-F238E27FC236}">
-                <a16:creationId xmlns:a16="http://schemas.microsoft.com/office/drawing/2014/main" id="{4E9A3E7E-FAE7-425B-A7A4-6D115924C701}"/>
+                <a16:creationId xmlns:a16="http://schemas.microsoft.com/office/drawing/2014/main" id="{693A6868-AD6A-41C0-A42B-B037A53CF534}"/>
               </a:ext>
             </a:extLst>
           </p:cNvPr>
@@ -8680,7 +8680,7 @@
         </p:xfrm>
         <a:graphic xmlns:a="http://schemas.openxmlformats.org/drawingml/2006/main">
           <a:graphicData uri="http://schemas.openxmlformats.org/drawingml/2006/chart">
-            <c:chart xmlns:r="http://schemas.openxmlformats.org/officeDocument/2006/relationships" xmlns:c="http://schemas.openxmlformats.org/drawingml/2006/chart" r:id="Rb3cdce87cf6f4a08"/>
+            <c:chart xmlns:r="http://schemas.openxmlformats.org/officeDocument/2006/relationships" xmlns:c="http://schemas.openxmlformats.org/drawingml/2006/chart" r:id="Ref23cf776979480c"/>
           </a:graphicData>
         </a:graphic>
       </p:graphicFrame>
@@ -8689,7 +8689,7 @@
           <p:cNvPr id="5" name="">
             <a:extLst xmlns:a="http://schemas.openxmlformats.org/drawingml/2006/main">
               <a:ext uri="{FF2B5EF4-FFF2-40B4-BE49-F238E27FC236}">
-                <a16:creationId xmlns:a16="http://schemas.microsoft.com/office/drawing/2014/main" id="{4896B813-1B7D-4FB5-8259-7BC13AAF905C}"/>
+                <a16:creationId xmlns:a16="http://schemas.microsoft.com/office/drawing/2014/main" id="{61C7BF5B-278F-445C-B53E-557A12D37FF7}"/>
               </a:ext>
             </a:extLst>
           </p:cNvPr>
@@ -8757,7 +8757,7 @@
           <p:cNvPr id="6" name="">
             <a:extLst xmlns:a="http://schemas.openxmlformats.org/drawingml/2006/main">
               <a:ext uri="{FF2B5EF4-FFF2-40B4-BE49-F238E27FC236}">
-                <a16:creationId xmlns:a16="http://schemas.microsoft.com/office/drawing/2014/main" id="{748070FF-34B2-4138-8161-3AE9446CCD0B}"/>
+                <a16:creationId xmlns:a16="http://schemas.microsoft.com/office/drawing/2014/main" id="{DC9364CA-998B-4778-AAF5-FF5D62FE7E9B}"/>
               </a:ext>
             </a:extLst>
           </p:cNvPr>
@@ -8825,7 +8825,7 @@
           <p:cNvPr id="7" name="">
             <a:extLst xmlns:a="http://schemas.openxmlformats.org/drawingml/2006/main">
               <a:ext uri="{FF2B5EF4-FFF2-40B4-BE49-F238E27FC236}">
-                <a16:creationId xmlns:a16="http://schemas.microsoft.com/office/drawing/2014/main" id="{E1B7FA8A-ED48-476A-A9B7-6AD93F672DC7}"/>
+                <a16:creationId xmlns:a16="http://schemas.microsoft.com/office/drawing/2014/main" id="{E0E3A6EC-A2C6-4C8E-BFC8-5256D77B1D74}"/>
               </a:ext>
             </a:extLst>
           </p:cNvPr>
@@ -8893,7 +8893,7 @@
           <p:cNvPr id="8" name="">
             <a:extLst xmlns:a="http://schemas.openxmlformats.org/drawingml/2006/main">
               <a:ext uri="{FF2B5EF4-FFF2-40B4-BE49-F238E27FC236}">
-                <a16:creationId xmlns:a16="http://schemas.microsoft.com/office/drawing/2014/main" id="{AC170245-ADEE-4265-BD19-C5EB72C7CDA1}"/>
+                <a16:creationId xmlns:a16="http://schemas.microsoft.com/office/drawing/2014/main" id="{4B7A79BE-471B-482B-A8DF-82833B32053D}"/>
               </a:ext>
             </a:extLst>
           </p:cNvPr>
@@ -8961,7 +8961,7 @@
           <p:cNvPr id="9" name="">
             <a:extLst xmlns:a="http://schemas.openxmlformats.org/drawingml/2006/main">
               <a:ext uri="{FF2B5EF4-FFF2-40B4-BE49-F238E27FC236}">
-                <a16:creationId xmlns:a16="http://schemas.microsoft.com/office/drawing/2014/main" id="{81A6CA50-27F6-46A9-BC88-E49A3FEBD37F}"/>
+                <a16:creationId xmlns:a16="http://schemas.microsoft.com/office/drawing/2014/main" id="{7D4BE054-549C-42D1-9805-74BB3230E6C9}"/>
               </a:ext>
             </a:extLst>
           </p:cNvPr>
@@ -9029,7 +9029,7 @@
           <p:cNvPr id="10" name="">
             <a:extLst xmlns:a="http://schemas.openxmlformats.org/drawingml/2006/main">
               <a:ext uri="{FF2B5EF4-FFF2-40B4-BE49-F238E27FC236}">
-                <a16:creationId xmlns:a16="http://schemas.microsoft.com/office/drawing/2014/main" id="{B5E47B50-2CEB-4B2A-85EE-63A64125DD0F}"/>
+                <a16:creationId xmlns:a16="http://schemas.microsoft.com/office/drawing/2014/main" id="{5C483138-9E21-4594-A121-59E005E0D7B4}"/>
               </a:ext>
             </a:extLst>
           </p:cNvPr>
@@ -9095,7 +9095,7 @@
     </p:spTree>
     <p:extLst>
       <p:ext uri="{BB962C8B-B14F-4D97-AF65-F5344CB8AC3E}">
-        <p14:creationId xmlns:p14="http://schemas.microsoft.com/office/powerpoint/2010/main" val="212568378"/>
+        <p14:creationId xmlns:p14="http://schemas.microsoft.com/office/powerpoint/2010/main" val="921169008"/>
       </p:ext>
     </p:extLst>
   </p:cSld>
@@ -9126,7 +9126,7 @@
           <p:cNvPr id="13" name="">
             <a:extLst xmlns:a="http://schemas.openxmlformats.org/drawingml/2006/main">
               <a:ext uri="{FF2B5EF4-FFF2-40B4-BE49-F238E27FC236}">
-                <a16:creationId xmlns:a16="http://schemas.microsoft.com/office/drawing/2014/main" id="{06E302DC-67B6-4C17-BC11-4D0E7A4A654B}"/>
+                <a16:creationId xmlns:a16="http://schemas.microsoft.com/office/drawing/2014/main" id="{14BC0872-7B41-4B70-BE65-08055BDAFD1D}"/>
               </a:ext>
             </a:extLst>
           </p:cNvPr>
@@ -9194,7 +9194,7 @@
           <p:cNvPr id="2" name="">
             <a:extLst xmlns:a="http://schemas.openxmlformats.org/drawingml/2006/main">
               <a:ext uri="{FF2B5EF4-FFF2-40B4-BE49-F238E27FC236}">
-                <a16:creationId xmlns:a16="http://schemas.microsoft.com/office/drawing/2014/main" id="{C6188619-3102-47BD-A09C-FE59B530038B}"/>
+                <a16:creationId xmlns:a16="http://schemas.microsoft.com/office/drawing/2014/main" id="{459FB475-9BC1-4075-BF91-46518020D044}"/>
               </a:ext>
             </a:extLst>
           </p:cNvPr>
@@ -9262,7 +9262,7 @@
           <p:cNvPr id="3" name="">
             <a:extLst xmlns:a="http://schemas.openxmlformats.org/drawingml/2006/main">
               <a:ext uri="{FF2B5EF4-FFF2-40B4-BE49-F238E27FC236}">
-                <a16:creationId xmlns:a16="http://schemas.microsoft.com/office/drawing/2014/main" id="{04C98648-067D-4DD5-BDFA-2708EA8732C0}"/>
+                <a16:creationId xmlns:a16="http://schemas.microsoft.com/office/drawing/2014/main" id="{FB777E4F-67CF-4AD2-AB91-264A2112D3CE}"/>
               </a:ext>
             </a:extLst>
           </p:cNvPr>
@@ -9330,7 +9330,7 @@
           <p:cNvPr id="4" name="">
             <a:extLst xmlns:a="http://schemas.openxmlformats.org/drawingml/2006/main">
               <a:ext uri="{FF2B5EF4-FFF2-40B4-BE49-F238E27FC236}">
-                <a16:creationId xmlns:a16="http://schemas.microsoft.com/office/drawing/2014/main" id="{9CEAEB5F-44B9-4846-94AD-6000B8F6B084}"/>
+                <a16:creationId xmlns:a16="http://schemas.microsoft.com/office/drawing/2014/main" id="{F16F89D9-D13E-4F7E-A3B9-B807C35312CD}"/>
               </a:ext>
             </a:extLst>
           </p:cNvPr>
@@ -9398,7 +9398,7 @@
           <p:cNvPr id="5" name="">
             <a:extLst xmlns:a="http://schemas.openxmlformats.org/drawingml/2006/main">
               <a:ext uri="{FF2B5EF4-FFF2-40B4-BE49-F238E27FC236}">
-                <a16:creationId xmlns:a16="http://schemas.microsoft.com/office/drawing/2014/main" id="{67A74AA5-2DC3-4956-87A9-818AD821D9ED}"/>
+                <a16:creationId xmlns:a16="http://schemas.microsoft.com/office/drawing/2014/main" id="{03C778B8-162A-4076-ADFD-BE43F2427CC5}"/>
               </a:ext>
             </a:extLst>
           </p:cNvPr>
@@ -9466,7 +9466,7 @@
           <p:cNvPr id="6" name="">
             <a:extLst xmlns:a="http://schemas.openxmlformats.org/drawingml/2006/main">
               <a:ext uri="{FF2B5EF4-FFF2-40B4-BE49-F238E27FC236}">
-                <a16:creationId xmlns:a16="http://schemas.microsoft.com/office/drawing/2014/main" id="{485BE4E2-E935-4D2C-AB07-84AFA762D12C}"/>
+                <a16:creationId xmlns:a16="http://schemas.microsoft.com/office/drawing/2014/main" id="{BE0349B2-6A04-40B0-9C90-6B7031375A83}"/>
               </a:ext>
             </a:extLst>
           </p:cNvPr>
@@ -9534,7 +9534,7 @@
           <p:cNvPr id="7" name="">
             <a:extLst xmlns:a="http://schemas.openxmlformats.org/drawingml/2006/main">
               <a:ext uri="{FF2B5EF4-FFF2-40B4-BE49-F238E27FC236}">
-                <a16:creationId xmlns:a16="http://schemas.microsoft.com/office/drawing/2014/main" id="{B438E1B9-385A-42BA-875F-35A129D341B5}"/>
+                <a16:creationId xmlns:a16="http://schemas.microsoft.com/office/drawing/2014/main" id="{BE47DA4E-983D-45EE-9C0A-CF88D242A5CF}"/>
               </a:ext>
             </a:extLst>
           </p:cNvPr>
@@ -9602,7 +9602,7 @@
           <p:cNvPr id="8" name="">
             <a:extLst xmlns:a="http://schemas.openxmlformats.org/drawingml/2006/main">
               <a:ext uri="{FF2B5EF4-FFF2-40B4-BE49-F238E27FC236}">
-                <a16:creationId xmlns:a16="http://schemas.microsoft.com/office/drawing/2014/main" id="{610EA3AA-B6EA-4268-B646-87577487F4CE}"/>
+                <a16:creationId xmlns:a16="http://schemas.microsoft.com/office/drawing/2014/main" id="{077EDE57-2453-400B-AC2D-C51468703BF4}"/>
               </a:ext>
             </a:extLst>
           </p:cNvPr>
@@ -9670,7 +9670,7 @@
           <p:cNvPr id="9" name="">
             <a:extLst xmlns:a="http://schemas.openxmlformats.org/drawingml/2006/main">
               <a:ext uri="{FF2B5EF4-FFF2-40B4-BE49-F238E27FC236}">
-                <a16:creationId xmlns:a16="http://schemas.microsoft.com/office/drawing/2014/main" id="{02AD29A0-E6BA-4CE8-81D1-7FB9992E7E38}"/>
+                <a16:creationId xmlns:a16="http://schemas.microsoft.com/office/drawing/2014/main" id="{88BED26A-C278-428C-83E9-E1770F04C760}"/>
               </a:ext>
             </a:extLst>
           </p:cNvPr>
@@ -9738,7 +9738,7 @@
           <p:cNvPr id="10" name="">
             <a:extLst xmlns:a="http://schemas.openxmlformats.org/drawingml/2006/main">
               <a:ext uri="{FF2B5EF4-FFF2-40B4-BE49-F238E27FC236}">
-                <a16:creationId xmlns:a16="http://schemas.microsoft.com/office/drawing/2014/main" id="{594A496D-F9E8-45F4-A00E-7E8267BF4F3D}"/>
+                <a16:creationId xmlns:a16="http://schemas.microsoft.com/office/drawing/2014/main" id="{255BF181-BB62-4D81-9BDD-6354A4B8BE34}"/>
               </a:ext>
             </a:extLst>
           </p:cNvPr>
@@ -9806,7 +9806,7 @@
           <p:cNvPr id="11" name="">
             <a:extLst xmlns:a="http://schemas.openxmlformats.org/drawingml/2006/main">
               <a:ext uri="{FF2B5EF4-FFF2-40B4-BE49-F238E27FC236}">
-                <a16:creationId xmlns:a16="http://schemas.microsoft.com/office/drawing/2014/main" id="{D51D0F01-0E17-4DBB-9325-449C14DD7DDF}"/>
+                <a16:creationId xmlns:a16="http://schemas.microsoft.com/office/drawing/2014/main" id="{B5B27C35-AFB0-4148-9C5C-EFEB1D032DA0}"/>
               </a:ext>
             </a:extLst>
           </p:cNvPr>
@@ -9874,7 +9874,7 @@
           <p:cNvPr id="12" name="">
             <a:extLst xmlns:a="http://schemas.openxmlformats.org/drawingml/2006/main">
               <a:ext uri="{FF2B5EF4-FFF2-40B4-BE49-F238E27FC236}">
-                <a16:creationId xmlns:a16="http://schemas.microsoft.com/office/drawing/2014/main" id="{0EA27567-B8B1-4E9C-9F2A-31A499EA63C2}"/>
+                <a16:creationId xmlns:a16="http://schemas.microsoft.com/office/drawing/2014/main" id="{10394FCF-975B-4125-998B-216FE30434F9}"/>
               </a:ext>
             </a:extLst>
           </p:cNvPr>
@@ -9940,7 +9940,7 @@
     </p:spTree>
     <p:extLst>
       <p:ext uri="{BB962C8B-B14F-4D97-AF65-F5344CB8AC3E}">
-        <p14:creationId xmlns:p14="http://schemas.microsoft.com/office/powerpoint/2010/main" val="1708653895"/>
+        <p14:creationId xmlns:p14="http://schemas.microsoft.com/office/powerpoint/2010/main" val="1636491716"/>
       </p:ext>
     </p:extLst>
   </p:cSld>
@@ -9971,7 +9971,7 @@
           <p:cNvPr id="5" name="">
             <a:extLst xmlns:a="http://schemas.openxmlformats.org/drawingml/2006/main">
               <a:ext uri="{FF2B5EF4-FFF2-40B4-BE49-F238E27FC236}">
-                <a16:creationId xmlns:a16="http://schemas.microsoft.com/office/drawing/2014/main" id="{0341DC95-7E98-4017-892F-F934D67F2397}"/>
+                <a16:creationId xmlns:a16="http://schemas.microsoft.com/office/drawing/2014/main" id="{29389B93-1942-4F02-B467-FD01D9F5272A}"/>
               </a:ext>
             </a:extLst>
           </p:cNvPr>
@@ -10039,7 +10039,7 @@
           <p:cNvPr id="2" name="">
             <a:extLst xmlns:a="http://schemas.openxmlformats.org/drawingml/2006/main">
               <a:ext uri="{FF2B5EF4-FFF2-40B4-BE49-F238E27FC236}">
-                <a16:creationId xmlns:a16="http://schemas.microsoft.com/office/drawing/2014/main" id="{C912C81A-DFDB-49DC-A922-61F966157271}"/>
+                <a16:creationId xmlns:a16="http://schemas.microsoft.com/office/drawing/2014/main" id="{620D7F52-0A3C-46A5-9F62-3D4337715675}"/>
               </a:ext>
             </a:extLst>
           </p:cNvPr>
@@ -10107,7 +10107,7 @@
           <p:cNvPr id="3" name="">
             <a:extLst xmlns:a="http://schemas.openxmlformats.org/drawingml/2006/main">
               <a:ext uri="{FF2B5EF4-FFF2-40B4-BE49-F238E27FC236}">
-                <a16:creationId xmlns:a16="http://schemas.microsoft.com/office/drawing/2014/main" id="{57C62956-B766-405E-9F7C-116A2CB988BC}"/>
+                <a16:creationId xmlns:a16="http://schemas.microsoft.com/office/drawing/2014/main" id="{984201E1-5357-4855-85D5-47E23ABDCA42}"/>
               </a:ext>
             </a:extLst>
           </p:cNvPr>
@@ -10244,7 +10244,7 @@
           <p:cNvPr id="4" name="">
             <a:extLst xmlns:a="http://schemas.openxmlformats.org/drawingml/2006/main">
               <a:ext uri="{FF2B5EF4-FFF2-40B4-BE49-F238E27FC236}">
-                <a16:creationId xmlns:a16="http://schemas.microsoft.com/office/drawing/2014/main" id="{32BB1ED2-81AC-49A0-95CE-43C36D594F12}"/>
+                <a16:creationId xmlns:a16="http://schemas.microsoft.com/office/drawing/2014/main" id="{ED025011-1C76-46B2-A9EE-B6C9BC8C8F9E}"/>
               </a:ext>
             </a:extLst>
           </p:cNvPr>
@@ -10310,7 +10310,7 @@
     </p:spTree>
     <p:extLst>
       <p:ext uri="{BB962C8B-B14F-4D97-AF65-F5344CB8AC3E}">
-        <p14:creationId xmlns:p14="http://schemas.microsoft.com/office/powerpoint/2010/main" val="1776490496"/>
+        <p14:creationId xmlns:p14="http://schemas.microsoft.com/office/powerpoint/2010/main" val="31450285"/>
       </p:ext>
     </p:extLst>
   </p:cSld>

</xml_diff>

<commit_message>
docs: capture verified EC2 demo and midpoint evidence
</commit_message>
<xml_diff>
--- a/docs/midpoint/GroupUNKNOWN-aiplatform.pptx
+++ b/docs/midpoint/GroupUNKNOWN-aiplatform.pptx
@@ -2,20 +2,20 @@
 <file path=ppt/presentation.xml><?xml version="1.0" encoding="utf-8"?>
 <p:presentation xmlns:p="http://schemas.openxmlformats.org/presentationml/2006/main">
   <p:sldMasterIdLst>
-    <p:sldMasterId xmlns:r="http://schemas.openxmlformats.org/officeDocument/2006/relationships" id="2147483648" r:id="R6fd9f31498b247cc"/>
+    <p:sldMasterId xmlns:r="http://schemas.openxmlformats.org/officeDocument/2006/relationships" id="2147483648" r:id="R672948d799754847"/>
   </p:sldMasterIdLst>
   <p:notesMasterIdLst>
-    <p:notesMasterId xmlns:r="http://schemas.openxmlformats.org/officeDocument/2006/relationships" r:id="R546c82daeb564b7e"/>
+    <p:notesMasterId xmlns:r="http://schemas.openxmlformats.org/officeDocument/2006/relationships" r:id="R9c10bd9fd3254e3e"/>
   </p:notesMasterIdLst>
   <p:sldIdLst>
-    <p:sldId xmlns:r="http://schemas.openxmlformats.org/officeDocument/2006/relationships" id="256" r:id="R6eb6e1e3064a4c10"/>
-    <p:sldId xmlns:r="http://schemas.openxmlformats.org/officeDocument/2006/relationships" id="257" r:id="R44d9c46392f64179"/>
-    <p:sldId xmlns:r="http://schemas.openxmlformats.org/officeDocument/2006/relationships" id="258" r:id="R473ab0c0f76a45d2"/>
-    <p:sldId xmlns:r="http://schemas.openxmlformats.org/officeDocument/2006/relationships" id="259" r:id="Rfde98412f34b4e41"/>
-    <p:sldId xmlns:r="http://schemas.openxmlformats.org/officeDocument/2006/relationships" id="260" r:id="Rbc4118836e6f43d2"/>
-    <p:sldId xmlns:r="http://schemas.openxmlformats.org/officeDocument/2006/relationships" id="261" r:id="R136c6d22538948dd"/>
-    <p:sldId xmlns:r="http://schemas.openxmlformats.org/officeDocument/2006/relationships" id="262" r:id="R7a5ebdcf38b24460"/>
-    <p:sldId xmlns:r="http://schemas.openxmlformats.org/officeDocument/2006/relationships" id="263" r:id="R9cac1911f19d4420"/>
+    <p:sldId xmlns:r="http://schemas.openxmlformats.org/officeDocument/2006/relationships" id="256" r:id="R0ee7edc800894c66"/>
+    <p:sldId xmlns:r="http://schemas.openxmlformats.org/officeDocument/2006/relationships" id="257" r:id="Rab08567681c3496a"/>
+    <p:sldId xmlns:r="http://schemas.openxmlformats.org/officeDocument/2006/relationships" id="258" r:id="R20589325f066444b"/>
+    <p:sldId xmlns:r="http://schemas.openxmlformats.org/officeDocument/2006/relationships" id="259" r:id="Re30a718471df4eb4"/>
+    <p:sldId xmlns:r="http://schemas.openxmlformats.org/officeDocument/2006/relationships" id="260" r:id="Rcc077c5f1dcd450a"/>
+    <p:sldId xmlns:r="http://schemas.openxmlformats.org/officeDocument/2006/relationships" id="261" r:id="R5be17317cc1c4e91"/>
+    <p:sldId xmlns:r="http://schemas.openxmlformats.org/officeDocument/2006/relationships" id="262" r:id="R5620fb3a0af04719"/>
+    <p:sldId xmlns:r="http://schemas.openxmlformats.org/officeDocument/2006/relationships" id="263" r:id="Redfd05546f1c455d"/>
   </p:sldIdLst>
   <p:sldSz cx="12192000" cy="6858000"/>
   <p:notesSz cx="6858000" cy="9144000"/>
@@ -459,7 +459,7 @@
           </a:p>
           <a:p xmlns:a="http://schemas.openxmlformats.org/drawingml/2006/main">
             <a:r>
-              <a:t>My project is aiplatform, a self-service infrastructure platform for open-source model workloads. I am John Cobio. The goal is to give a developer a small configuration file and a repeatable path to deployment, health checks, and operational metrics. Today I will show the implemented prototype, evidence from tests and experiments, and the next cloud milestone.</a:t>
+              <a:t>My project is aiplatform, a self-service infrastructure platform for open-source model workloads. I am John Cobio. The goal is to give a developer a small configuration file and a repeatable path to deployment, health checks, and operational metrics. Today I will show the local prototype, a verified EC2 model-serving demo, evidence from tests and experiments, and remaining work.</a:t>
             </a:r>
           </a:p>
           <a:p xmlns:a="http://schemas.openxmlformats.org/drawingml/2006/main">
@@ -649,7 +649,7 @@
           </a:p>
           <a:p xmlns:a="http://schemas.openxmlformats.org/drawingml/2006/main">
             <a:r>
-              <a:t>This is the implemented prototype architecture. GitHub Actions runs validation and publishes images to GHCR. Locally, the CLI can deploy directly with Helm or commit desired state for Argo CD to reconcile. Ingress routes requests to an inference pod, which caches model weights on a persistent volume. Prometheus and Grafana expose performance and resource use. The built-in service also exports OpenTelemetry traces to Jaeger. These components have run locally, but Docker is currently stopped on the audit machine, so a live endpoint must be rechecked before the recording.</a:t>
+              <a:t>This is the local prototype architecture. GitHub Actions runs validation and publishes images to GHCR. The CLI can deploy directly with Helm or commit desired state for Argo CD to reconcile. Ingress routes requests to an inference pod and a persistent volume caches model weights. Prometheus and Grafana expose performance and resource use. The built-in service exports OpenTelemetry traces to Jaeger. These components have run locally. The current live midpoint demo uses the smaller EC2 footprint on the next slide, so the laptop does not need to run the whole cluster during recording.</a:t>
             </a:r>
           </a:p>
           <a:p xmlns:a="http://schemas.openxmlformats.org/drawingml/2006/main">
@@ -744,7 +744,7 @@
           </a:p>
           <a:p xmlns:a="http://schemas.openxmlformats.org/drawingml/2006/main">
             <a:r>
-              <a:t>The next cloud milestone is deliberately small: an EC2 instance serving a real model, in a public subnet, with a security group limited to my IP and encrypted EBS for the cache. The inspected Academy sandbox restricts IAM to read-only, supports t2 and t3 instances, and requires gp2 storage. ECR and EKS are not listed among its supported services, so the first cloud demo would pull the existing public image from GHCR. This slide shows a plan, not a completed deployment. I will replace that status only after a successful cloud inference request.</a:t>
+              <a:t>The cloud milestone now runs a real Qwen model on one EC2 instance. Terraform applied a reviewed plan with four creates and no changes to existing lab resources. It reuses the lab network and restricts port 8000 to my IP. The instance has encrypted gp2 storage, standard CPU credits, no SSH and no IAM role. It pulls a digest-pinned public image and verifies the model checksum. One real request returned HTTP 200 with 34 output tokens in 2.304 seconds of client time. That is a smoke test, not a P95 benchmark. The host schedules termination after two hours, and Terraform destroy removes the remaining security group.</a:t>
             </a:r>
           </a:p>
           <a:p xmlns:a="http://schemas.openxmlformats.org/drawingml/2006/main">
@@ -759,7 +759,7 @@
           </a:p>
           <a:p xmlns:a="http://schemas.openxmlformats.org/drawingml/2006/main">
             <a:r>
-              <a:t>Academy Cloud Architecting 3 Sandbox instructions viewed October 15, 2026; docs/midpoint/CLOUD_SETUP.md. Pricing reference https://aws.amazon.com/vpc/pricing/ and https://aws.amazon.com/eks/pricing/.</a:t>
+              <a:t>docs/benchmarks/2026-10-15-academy-smoke.md: verified 2026-10-16 01:15:18 UTC (October 15 locally). infra/terraform/environments/academy; ADR 0012. No EKS/ECR/GPU deployment is claimed.</a:t>
             </a:r>
           </a:p>
         </p:txBody>
@@ -839,7 +839,7 @@
           </a:p>
           <a:p xmlns:a="http://schemas.openxmlformats.org/drawingml/2006/main">
             <a:r>
-              <a:t>The platform has automation beyond the inference endpoint. The fresh audit passed 112 CLI and 14 service tests. Terraform formatting and validation, chart render checks, and policy suites also passed. The audit reproduced an earlier pipeline failure caused by an unfiltered availability-zone lookup. The repair pins zone identities and passed 83 local Checkov checks. All seven GitHub CI jobs then passed on commit 111610a. The lesson is to verify the current pipeline rather than rely on an old badge. Terraform validation is still distinct from proving a cloud apply.</a:t>
+              <a:t>The fresh audit passed 112 CLI and 14 service tests. Seven Terraform roots and modules validate. Three mocked Terraform plans test the Academy constraints, and four OPA unit tests check its narrow instance-type exception. Chart checks and both policy suites passed. Checkov passed 102 checks with one documented exception for the intentionally role-free host. All seven CI jobs passed on ed73116. Earlier in the audit, a real scanner failure led to an explicit availability-zone filter rather than a global suppression. Validation, a cloud apply, and model readiness are separate checks.</a:t>
             </a:r>
           </a:p>
           <a:p xmlns:a="http://schemas.openxmlformats.org/drawingml/2006/main">
@@ -854,7 +854,7 @@
           </a:p>
           <a:p xmlns:a="http://schemas.openxmlformats.org/drawingml/2006/main">
             <a:r>
-              <a:t>October 15 make check: 112 CLI + 14 service tests, six Terraform checks, chart checks and policy checks; Checkov reproduced CKV_AWS_394 then passed 83 checks after explicit zone-name filter. Verified successful CI https://github.com/johncobio/aiplatform/actions/runs/38820810497</a:t>
+              <a:t>make check: 112 CLI + 14 service tests, seven Terraform validations, three mocked plans, four OPA unit tests, 364 Terraform and 80 Kubernetes policy assertions. Checkov: 102 passed, 0 failed, 1 scoped skip. CI https://github.com/johncobio/aiplatform/actions/runs/38822074273</a:t>
             </a:r>
           </a:p>
         </p:txBody>
@@ -1029,7 +1029,7 @@
           </a:p>
           <a:p xmlns:a="http://schemas.openxmlformats.org/drawingml/2006/main">
             <a:r>
-              <a:t>The main challenge has been resource pressure on an eight-gigabyte laptop, so the demo uses one workload and pauses unused add-ons. Academy permissions are another constraint, which is why EC2 is the immediate cloud milestone. The reliability work found an ingress blind spot that needs an external probe. EKS, GPU inference, and the live proposal provider remain unverified. After feedback I will prioritise cloud automation and repeat the load and recovery measurements in the selected account. The final deadline still needs confirmation.</a:t>
+              <a:t>The main challenge has been resource pressure on an eight-gigabyte laptop, which led to using one local workload and pausing unused add-ons. The live recording can now use EC2 instead. Academy permissions shaped that smaller cloud footprint. The reliability work found an ingress blind spot that needs an external probe. EKS, GPU inference, and the live proposal provider remain unverified. After feedback I will extend cloud automation and repeat load and recovery measurements. The current EC2 demo is temporary and must be destroyed after recording. The final deadline still needs confirmation.</a:t>
             </a:r>
           </a:p>
           <a:p xmlns:a="http://schemas.openxmlformats.org/drawingml/2006/main">
@@ -1186,7 +1186,7 @@
           <p:cNvPr id="3" name="Title">
             <a:extLst xmlns:a="http://schemas.openxmlformats.org/drawingml/2006/main">
               <a:ext uri="{FF2B5EF4-FFF2-40B4-BE49-F238E27FC236}">
-                <a16:creationId xmlns:a16="http://schemas.microsoft.com/office/drawing/2014/main" id="{6ACB5573-E75E-4FEE-ABFE-C2C4A2A139D5}"/>
+                <a16:creationId xmlns:a16="http://schemas.microsoft.com/office/drawing/2014/main" id="{8982C53E-C37A-424E-9077-743F60350911}"/>
               </a:ext>
             </a:extLst>
           </p:cNvPr>
@@ -1343,7 +1343,7 @@
           <p:cNvPr id="2" name="Subtitle">
             <a:extLst xmlns:a="http://schemas.openxmlformats.org/drawingml/2006/main">
               <a:ext uri="{FF2B5EF4-FFF2-40B4-BE49-F238E27FC236}">
-                <a16:creationId xmlns:a16="http://schemas.microsoft.com/office/drawing/2014/main" id="{A3A2143D-A57C-4589-9A65-11AB9833CFA1}"/>
+                <a16:creationId xmlns:a16="http://schemas.microsoft.com/office/drawing/2014/main" id="{B30A27ED-109F-4544-93B7-FD91189B247D}"/>
               </a:ext>
             </a:extLst>
           </p:cNvPr>
@@ -1517,7 +1517,7 @@
           <p:cNvPr id="2" name="Section title">
             <a:extLst xmlns:a="http://schemas.openxmlformats.org/drawingml/2006/main">
               <a:ext uri="{FF2B5EF4-FFF2-40B4-BE49-F238E27FC236}">
-                <a16:creationId xmlns:a16="http://schemas.microsoft.com/office/drawing/2014/main" id="{42553B61-5803-4CDD-AA69-6292FED744C0}"/>
+                <a16:creationId xmlns:a16="http://schemas.microsoft.com/office/drawing/2014/main" id="{12B3600D-65A9-4D9F-B00A-F543BEB0D1D7}"/>
               </a:ext>
             </a:extLst>
           </p:cNvPr>
@@ -1691,7 +1691,7 @@
           <p:cNvPr id="3" name="Title">
             <a:extLst xmlns:a="http://schemas.openxmlformats.org/drawingml/2006/main">
               <a:ext uri="{FF2B5EF4-FFF2-40B4-BE49-F238E27FC236}">
-                <a16:creationId xmlns:a16="http://schemas.microsoft.com/office/drawing/2014/main" id="{6A62E598-5287-475A-8B22-C2A63BA35BE4}"/>
+                <a16:creationId xmlns:a16="http://schemas.microsoft.com/office/drawing/2014/main" id="{8A8973C6-B870-494E-BBBF-C0292498476A}"/>
               </a:ext>
             </a:extLst>
           </p:cNvPr>
@@ -1848,7 +1848,7 @@
           <p:cNvPr id="2" name="Body">
             <a:extLst xmlns:a="http://schemas.openxmlformats.org/drawingml/2006/main">
               <a:ext uri="{FF2B5EF4-FFF2-40B4-BE49-F238E27FC236}">
-                <a16:creationId xmlns:a16="http://schemas.microsoft.com/office/drawing/2014/main" id="{C39EE02C-49CB-4CED-8B1C-9F1FFF1F85CC}"/>
+                <a16:creationId xmlns:a16="http://schemas.microsoft.com/office/drawing/2014/main" id="{2013135D-4437-44AF-9E50-57D18041EE87}"/>
               </a:ext>
             </a:extLst>
           </p:cNvPr>
@@ -2022,7 +2022,7 @@
           <p:cNvPr id="4" name="Title">
             <a:extLst xmlns:a="http://schemas.openxmlformats.org/drawingml/2006/main">
               <a:ext uri="{FF2B5EF4-FFF2-40B4-BE49-F238E27FC236}">
-                <a16:creationId xmlns:a16="http://schemas.microsoft.com/office/drawing/2014/main" id="{C4F3BD03-3280-4563-A2BF-825ED1FCEE41}"/>
+                <a16:creationId xmlns:a16="http://schemas.microsoft.com/office/drawing/2014/main" id="{436F5C5E-8983-4AE2-B8B2-6B1C4011439D}"/>
               </a:ext>
             </a:extLst>
           </p:cNvPr>
@@ -2179,7 +2179,7 @@
           <p:cNvPr id="2" name="Left column">
             <a:extLst xmlns:a="http://schemas.openxmlformats.org/drawingml/2006/main">
               <a:ext uri="{FF2B5EF4-FFF2-40B4-BE49-F238E27FC236}">
-                <a16:creationId xmlns:a16="http://schemas.microsoft.com/office/drawing/2014/main" id="{11D0A781-31DB-481F-85D8-23B67D67AE8A}"/>
+                <a16:creationId xmlns:a16="http://schemas.microsoft.com/office/drawing/2014/main" id="{3686AA22-3253-4039-B967-7604B24FE0D7}"/>
               </a:ext>
             </a:extLst>
           </p:cNvPr>
@@ -2336,7 +2336,7 @@
           <p:cNvPr id="3" name="Right column">
             <a:extLst xmlns:a="http://schemas.openxmlformats.org/drawingml/2006/main">
               <a:ext uri="{FF2B5EF4-FFF2-40B4-BE49-F238E27FC236}">
-                <a16:creationId xmlns:a16="http://schemas.microsoft.com/office/drawing/2014/main" id="{915EFEAF-0F8E-44DE-8E12-24A17948E7D7}"/>
+                <a16:creationId xmlns:a16="http://schemas.microsoft.com/office/drawing/2014/main" id="{436CE059-2EC2-4F9D-8E4C-C3734C0AFD5B}"/>
               </a:ext>
             </a:extLst>
           </p:cNvPr>
@@ -2510,7 +2510,7 @@
           <p:cNvPr id="3" name="Title">
             <a:extLst xmlns:a="http://schemas.openxmlformats.org/drawingml/2006/main">
               <a:ext uri="{FF2B5EF4-FFF2-40B4-BE49-F238E27FC236}">
-                <a16:creationId xmlns:a16="http://schemas.microsoft.com/office/drawing/2014/main" id="{6D4A70F3-8F12-40D2-B11B-4D349BF82E12}"/>
+                <a16:creationId xmlns:a16="http://schemas.microsoft.com/office/drawing/2014/main" id="{DDE31E77-5CCC-4842-ABC8-13FF18C5BD35}"/>
               </a:ext>
             </a:extLst>
           </p:cNvPr>
@@ -2667,7 +2667,7 @@
           <p:cNvPr id="2" name="Left column">
             <a:extLst xmlns:a="http://schemas.openxmlformats.org/drawingml/2006/main">
               <a:ext uri="{FF2B5EF4-FFF2-40B4-BE49-F238E27FC236}">
-                <a16:creationId xmlns:a16="http://schemas.microsoft.com/office/drawing/2014/main" id="{3E59CB20-F865-40E3-B8DF-D8BDAB0034E9}"/>
+                <a16:creationId xmlns:a16="http://schemas.microsoft.com/office/drawing/2014/main" id="{7E5F1701-14CC-4E32-A775-2371A2970A04}"/>
               </a:ext>
             </a:extLst>
           </p:cNvPr>
@@ -2862,12 +2862,12 @@
   </p:cSld>
   <p:clrMap bg1="lt1" tx1="dk1" bg2="lt2" tx2="dk2" accent1="accent1" accent2="accent2" accent3="accent3" accent4="accent4" accent5="accent5" accent6="accent6" hlink="hlink" folHlink="folHlink"/>
   <p:sldLayoutIdLst>
-    <p:sldLayoutId xmlns:r="http://schemas.openxmlformats.org/officeDocument/2006/relationships" id="2147483649" r:id="Rc10070be867247d6"/>
-    <p:sldLayoutId xmlns:r="http://schemas.openxmlformats.org/officeDocument/2006/relationships" id="2147483650" r:id="R68017a2dbae84baf"/>
-    <p:sldLayoutId xmlns:r="http://schemas.openxmlformats.org/officeDocument/2006/relationships" id="2147483651" r:id="Re9fa479c83bf4ab4"/>
-    <p:sldLayoutId xmlns:r="http://schemas.openxmlformats.org/officeDocument/2006/relationships" id="2147483652" r:id="Rb1c91bb68b97440d"/>
-    <p:sldLayoutId xmlns:r="http://schemas.openxmlformats.org/officeDocument/2006/relationships" id="2147483653" r:id="Re69df6139ada4bc7"/>
-    <p:sldLayoutId xmlns:r="http://schemas.openxmlformats.org/officeDocument/2006/relationships" id="2147483654" r:id="Rea30dcaf4f7a42eb"/>
+    <p:sldLayoutId xmlns:r="http://schemas.openxmlformats.org/officeDocument/2006/relationships" id="2147483649" r:id="R648bda15d59d4d14"/>
+    <p:sldLayoutId xmlns:r="http://schemas.openxmlformats.org/officeDocument/2006/relationships" id="2147483650" r:id="R4360778eb0db4d82"/>
+    <p:sldLayoutId xmlns:r="http://schemas.openxmlformats.org/officeDocument/2006/relationships" id="2147483651" r:id="Racdfd7537c6e4d20"/>
+    <p:sldLayoutId xmlns:r="http://schemas.openxmlformats.org/officeDocument/2006/relationships" id="2147483652" r:id="R18a51139afdf4a63"/>
+    <p:sldLayoutId xmlns:r="http://schemas.openxmlformats.org/officeDocument/2006/relationships" id="2147483653" r:id="R4ad5735692bf4d4f"/>
+    <p:sldLayoutId xmlns:r="http://schemas.openxmlformats.org/officeDocument/2006/relationships" id="2147483654" r:id="R357d19844cc4477f"/>
   </p:sldLayoutIdLst>
   <p:txStyles>
     <p:titleStyle>
@@ -3578,7 +3578,7 @@
           <p:cNvPr id="6" name="">
             <a:extLst xmlns:a="http://schemas.openxmlformats.org/drawingml/2006/main">
               <a:ext uri="{FF2B5EF4-FFF2-40B4-BE49-F238E27FC236}">
-                <a16:creationId xmlns:a16="http://schemas.microsoft.com/office/drawing/2014/main" id="{79D8222A-9EB7-4D8A-9FA1-34FA68058D01}"/>
+                <a16:creationId xmlns:a16="http://schemas.microsoft.com/office/drawing/2014/main" id="{BB413649-C43D-46ED-864E-FD9EAE6D4C3E}"/>
               </a:ext>
             </a:extLst>
           </p:cNvPr>
@@ -3646,7 +3646,7 @@
           <p:cNvPr id="2" name="">
             <a:extLst xmlns:a="http://schemas.openxmlformats.org/drawingml/2006/main">
               <a:ext uri="{FF2B5EF4-FFF2-40B4-BE49-F238E27FC236}">
-                <a16:creationId xmlns:a16="http://schemas.microsoft.com/office/drawing/2014/main" id="{C61A5C2F-BFC5-4953-93DD-655D4C8D1F7E}"/>
+                <a16:creationId xmlns:a16="http://schemas.microsoft.com/office/drawing/2014/main" id="{66DDC285-2F89-4C98-984F-AFAC22AFC2CD}"/>
               </a:ext>
             </a:extLst>
           </p:cNvPr>
@@ -3714,7 +3714,7 @@
           <p:cNvPr id="3" name="">
             <a:extLst xmlns:a="http://schemas.openxmlformats.org/drawingml/2006/main">
               <a:ext uri="{FF2B5EF4-FFF2-40B4-BE49-F238E27FC236}">
-                <a16:creationId xmlns:a16="http://schemas.microsoft.com/office/drawing/2014/main" id="{60FA9785-861F-461D-90EF-4848EF929122}"/>
+                <a16:creationId xmlns:a16="http://schemas.microsoft.com/office/drawing/2014/main" id="{CCE3007D-D00D-402F-A70E-38DFDD3FCDDE}"/>
               </a:ext>
             </a:extLst>
           </p:cNvPr>
@@ -3782,7 +3782,7 @@
           <p:cNvPr id="4" name="">
             <a:extLst xmlns:a="http://schemas.openxmlformats.org/drawingml/2006/main">
               <a:ext uri="{FF2B5EF4-FFF2-40B4-BE49-F238E27FC236}">
-                <a16:creationId xmlns:a16="http://schemas.microsoft.com/office/drawing/2014/main" id="{7541D08C-81EF-49FB-A22A-5735D1231294}"/>
+                <a16:creationId xmlns:a16="http://schemas.microsoft.com/office/drawing/2014/main" id="{6829A211-3AD9-47D0-819E-F425BF4CD58A}"/>
               </a:ext>
             </a:extLst>
           </p:cNvPr>
@@ -3873,7 +3873,7 @@
           <p:cNvPr id="5" name="">
             <a:extLst xmlns:a="http://schemas.openxmlformats.org/drawingml/2006/main">
               <a:ext uri="{FF2B5EF4-FFF2-40B4-BE49-F238E27FC236}">
-                <a16:creationId xmlns:a16="http://schemas.microsoft.com/office/drawing/2014/main" id="{BBC2FED9-EE80-4BEC-AB5B-440779F8D498}"/>
+                <a16:creationId xmlns:a16="http://schemas.microsoft.com/office/drawing/2014/main" id="{8ABEDECA-90F1-458A-A1AA-FC8B85BEE7A8}"/>
               </a:ext>
             </a:extLst>
           </p:cNvPr>
@@ -3962,7 +3962,7 @@
     </p:spTree>
     <p:extLst>
       <p:ext uri="{BB962C8B-B14F-4D97-AF65-F5344CB8AC3E}">
-        <p14:creationId xmlns:p14="http://schemas.microsoft.com/office/powerpoint/2010/main" val="609398141"/>
+        <p14:creationId xmlns:p14="http://schemas.microsoft.com/office/powerpoint/2010/main" val="1341162111"/>
       </p:ext>
     </p:extLst>
   </p:cSld>
@@ -3993,7 +3993,7 @@
           <p:cNvPr id="13" name="">
             <a:extLst xmlns:a="http://schemas.openxmlformats.org/drawingml/2006/main">
               <a:ext uri="{FF2B5EF4-FFF2-40B4-BE49-F238E27FC236}">
-                <a16:creationId xmlns:a16="http://schemas.microsoft.com/office/drawing/2014/main" id="{1C544D8D-C7AB-4871-9512-75C272830BE1}"/>
+                <a16:creationId xmlns:a16="http://schemas.microsoft.com/office/drawing/2014/main" id="{163A14FD-636A-47C3-87B0-C2D19FC33C40}"/>
               </a:ext>
             </a:extLst>
           </p:cNvPr>
@@ -4061,7 +4061,7 @@
           <p:cNvPr id="2" name="">
             <a:extLst xmlns:a="http://schemas.openxmlformats.org/drawingml/2006/main">
               <a:ext uri="{FF2B5EF4-FFF2-40B4-BE49-F238E27FC236}">
-                <a16:creationId xmlns:a16="http://schemas.microsoft.com/office/drawing/2014/main" id="{099E42CC-FF15-42AA-B6E8-3254E88C9DCF}"/>
+                <a16:creationId xmlns:a16="http://schemas.microsoft.com/office/drawing/2014/main" id="{A242CB78-0A48-4467-8306-389FE8BC2012}"/>
               </a:ext>
             </a:extLst>
           </p:cNvPr>
@@ -4129,7 +4129,7 @@
           <p:cNvPr id="3" name="">
             <a:extLst xmlns:a="http://schemas.openxmlformats.org/drawingml/2006/main">
               <a:ext uri="{FF2B5EF4-FFF2-40B4-BE49-F238E27FC236}">
-                <a16:creationId xmlns:a16="http://schemas.microsoft.com/office/drawing/2014/main" id="{1BD90414-CD8E-45C9-8E51-0F5BCE2AF8A1}"/>
+                <a16:creationId xmlns:a16="http://schemas.microsoft.com/office/drawing/2014/main" id="{30077F3F-4A9A-4EEE-A74F-4E2505E310CB}"/>
               </a:ext>
             </a:extLst>
           </p:cNvPr>
@@ -4197,7 +4197,7 @@
           <p:cNvPr id="4" name="">
             <a:extLst xmlns:a="http://schemas.openxmlformats.org/drawingml/2006/main">
               <a:ext uri="{FF2B5EF4-FFF2-40B4-BE49-F238E27FC236}">
-                <a16:creationId xmlns:a16="http://schemas.microsoft.com/office/drawing/2014/main" id="{696B21B6-0A75-4D72-8087-968FAF86A442}"/>
+                <a16:creationId xmlns:a16="http://schemas.microsoft.com/office/drawing/2014/main" id="{D25D4D5C-ED40-438B-A22D-6F77C36ED268}"/>
               </a:ext>
             </a:extLst>
           </p:cNvPr>
@@ -4265,7 +4265,7 @@
           <p:cNvPr id="5" name="">
             <a:extLst xmlns:a="http://schemas.openxmlformats.org/drawingml/2006/main">
               <a:ext uri="{FF2B5EF4-FFF2-40B4-BE49-F238E27FC236}">
-                <a16:creationId xmlns:a16="http://schemas.microsoft.com/office/drawing/2014/main" id="{03F77A2C-00AD-4196-97A8-FF2B49D34086}"/>
+                <a16:creationId xmlns:a16="http://schemas.microsoft.com/office/drawing/2014/main" id="{AE5F15E4-4F89-4818-A6E1-2326570BEF98}"/>
               </a:ext>
             </a:extLst>
           </p:cNvPr>
@@ -4333,7 +4333,7 @@
           <p:cNvPr id="6" name="">
             <a:extLst xmlns:a="http://schemas.openxmlformats.org/drawingml/2006/main">
               <a:ext uri="{FF2B5EF4-FFF2-40B4-BE49-F238E27FC236}">
-                <a16:creationId xmlns:a16="http://schemas.microsoft.com/office/drawing/2014/main" id="{6F98E2AD-911F-42DF-9A6B-34C7AE865BAD}"/>
+                <a16:creationId xmlns:a16="http://schemas.microsoft.com/office/drawing/2014/main" id="{546013EB-0300-4B2A-B499-56902F951A8B}"/>
               </a:ext>
             </a:extLst>
           </p:cNvPr>
@@ -4401,7 +4401,7 @@
           <p:cNvPr id="7" name="">
             <a:extLst xmlns:a="http://schemas.openxmlformats.org/drawingml/2006/main">
               <a:ext uri="{FF2B5EF4-FFF2-40B4-BE49-F238E27FC236}">
-                <a16:creationId xmlns:a16="http://schemas.microsoft.com/office/drawing/2014/main" id="{44DEB960-32F4-4A04-BEC9-FC48548F163B}"/>
+                <a16:creationId xmlns:a16="http://schemas.microsoft.com/office/drawing/2014/main" id="{95C4ADD1-780A-4E23-8335-25A8BA04DCC5}"/>
               </a:ext>
             </a:extLst>
           </p:cNvPr>
@@ -4469,7 +4469,7 @@
           <p:cNvPr id="8" name="">
             <a:extLst xmlns:a="http://schemas.openxmlformats.org/drawingml/2006/main">
               <a:ext uri="{FF2B5EF4-FFF2-40B4-BE49-F238E27FC236}">
-                <a16:creationId xmlns:a16="http://schemas.microsoft.com/office/drawing/2014/main" id="{E4DE9424-A662-4C21-BF5B-A6F0669E1EC6}"/>
+                <a16:creationId xmlns:a16="http://schemas.microsoft.com/office/drawing/2014/main" id="{F0D2467C-D950-4DB3-825D-26F61AB04C8C}"/>
               </a:ext>
             </a:extLst>
           </p:cNvPr>
@@ -4537,7 +4537,7 @@
           <p:cNvPr id="9" name="">
             <a:extLst xmlns:a="http://schemas.openxmlformats.org/drawingml/2006/main">
               <a:ext uri="{FF2B5EF4-FFF2-40B4-BE49-F238E27FC236}">
-                <a16:creationId xmlns:a16="http://schemas.microsoft.com/office/drawing/2014/main" id="{164A3B7A-F744-4321-A4CD-C5971F85FCAF}"/>
+                <a16:creationId xmlns:a16="http://schemas.microsoft.com/office/drawing/2014/main" id="{0C93E662-CDE1-4FFB-89E8-25EFE5429305}"/>
               </a:ext>
             </a:extLst>
           </p:cNvPr>
@@ -4569,7 +4569,7 @@
           <p:cNvPr id="10" name="">
             <a:extLst xmlns:a="http://schemas.openxmlformats.org/drawingml/2006/main">
               <a:ext uri="{FF2B5EF4-FFF2-40B4-BE49-F238E27FC236}">
-                <a16:creationId xmlns:a16="http://schemas.microsoft.com/office/drawing/2014/main" id="{5FFF6A61-AB13-4C6E-A138-0629D3B79FE8}"/>
+                <a16:creationId xmlns:a16="http://schemas.microsoft.com/office/drawing/2014/main" id="{0AEB0FC5-FB24-4D01-B3C9-E7EC3EADD0A3}"/>
               </a:ext>
             </a:extLst>
           </p:cNvPr>
@@ -4637,7 +4637,7 @@
           <p:cNvPr id="11" name="">
             <a:extLst xmlns:a="http://schemas.openxmlformats.org/drawingml/2006/main">
               <a:ext uri="{FF2B5EF4-FFF2-40B4-BE49-F238E27FC236}">
-                <a16:creationId xmlns:a16="http://schemas.microsoft.com/office/drawing/2014/main" id="{83ABA320-DF21-44A7-BC7F-F56490C97498}"/>
+                <a16:creationId xmlns:a16="http://schemas.microsoft.com/office/drawing/2014/main" id="{507C8C24-1542-468A-A3D4-018B5D83A0F9}"/>
               </a:ext>
             </a:extLst>
           </p:cNvPr>
@@ -4820,7 +4820,7 @@
           <p:cNvPr id="12" name="">
             <a:extLst xmlns:a="http://schemas.openxmlformats.org/drawingml/2006/main">
               <a:ext uri="{FF2B5EF4-FFF2-40B4-BE49-F238E27FC236}">
-                <a16:creationId xmlns:a16="http://schemas.microsoft.com/office/drawing/2014/main" id="{73E926DC-E1D6-45E7-B059-E0DD48FB89D8}"/>
+                <a16:creationId xmlns:a16="http://schemas.microsoft.com/office/drawing/2014/main" id="{7B0C7D82-8091-4867-9207-C6E38AF0FFEC}"/>
               </a:ext>
             </a:extLst>
           </p:cNvPr>
@@ -4886,7 +4886,7 @@
     </p:spTree>
     <p:extLst>
       <p:ext uri="{BB962C8B-B14F-4D97-AF65-F5344CB8AC3E}">
-        <p14:creationId xmlns:p14="http://schemas.microsoft.com/office/powerpoint/2010/main" val="646010709"/>
+        <p14:creationId xmlns:p14="http://schemas.microsoft.com/office/powerpoint/2010/main" val="906475351"/>
       </p:ext>
     </p:extLst>
   </p:cSld>
@@ -4917,7 +4917,7 @@
           <p:cNvPr id="27" name="">
             <a:extLst xmlns:a="http://schemas.openxmlformats.org/drawingml/2006/main">
               <a:ext uri="{FF2B5EF4-FFF2-40B4-BE49-F238E27FC236}">
-                <a16:creationId xmlns:a16="http://schemas.microsoft.com/office/drawing/2014/main" id="{F88255A4-3509-4209-9C7E-98D4F61E0536}"/>
+                <a16:creationId xmlns:a16="http://schemas.microsoft.com/office/drawing/2014/main" id="{ECF725C5-C86D-42A4-8A96-259F8928D68F}"/>
               </a:ext>
             </a:extLst>
           </p:cNvPr>
@@ -4949,7 +4949,7 @@
           <p:cNvPr id="23" name="">
             <a:extLst xmlns:a="http://schemas.openxmlformats.org/drawingml/2006/main">
               <a:ext uri="{FF2B5EF4-FFF2-40B4-BE49-F238E27FC236}">
-                <a16:creationId xmlns:a16="http://schemas.microsoft.com/office/drawing/2014/main" id="{E3859CAB-F33E-4357-9DDE-5817F8B2FD48}"/>
+                <a16:creationId xmlns:a16="http://schemas.microsoft.com/office/drawing/2014/main" id="{22B0FA30-6002-4CAF-B75A-BD97ADF780AB}"/>
               </a:ext>
             </a:extLst>
           </p:cNvPr>
@@ -4981,7 +4981,7 @@
           <p:cNvPr id="22" name="">
             <a:extLst xmlns:a="http://schemas.openxmlformats.org/drawingml/2006/main">
               <a:ext uri="{FF2B5EF4-FFF2-40B4-BE49-F238E27FC236}">
-                <a16:creationId xmlns:a16="http://schemas.microsoft.com/office/drawing/2014/main" id="{99A7F26D-3855-4C48-8527-0B02A1538C35}"/>
+                <a16:creationId xmlns:a16="http://schemas.microsoft.com/office/drawing/2014/main" id="{BD23D75D-4229-4187-A4AB-B75B3B700E92}"/>
               </a:ext>
             </a:extLst>
           </p:cNvPr>
@@ -5013,7 +5013,7 @@
           <p:cNvPr id="21" name="">
             <a:extLst xmlns:a="http://schemas.openxmlformats.org/drawingml/2006/main">
               <a:ext uri="{FF2B5EF4-FFF2-40B4-BE49-F238E27FC236}">
-                <a16:creationId xmlns:a16="http://schemas.microsoft.com/office/drawing/2014/main" id="{45A0CC0F-0C6F-455A-A93B-A4B191781777}"/>
+                <a16:creationId xmlns:a16="http://schemas.microsoft.com/office/drawing/2014/main" id="{CB189E8F-4867-4964-B7EB-3836C8CC5153}"/>
               </a:ext>
             </a:extLst>
           </p:cNvPr>
@@ -5045,7 +5045,7 @@
           <p:cNvPr id="10" name="">
             <a:extLst xmlns:a="http://schemas.openxmlformats.org/drawingml/2006/main">
               <a:ext uri="{FF2B5EF4-FFF2-40B4-BE49-F238E27FC236}">
-                <a16:creationId xmlns:a16="http://schemas.microsoft.com/office/drawing/2014/main" id="{53033880-7171-471B-A340-3D69F39DF4D2}"/>
+                <a16:creationId xmlns:a16="http://schemas.microsoft.com/office/drawing/2014/main" id="{869BA77E-AA94-4CD4-B164-2F850B26CD72}"/>
               </a:ext>
             </a:extLst>
           </p:cNvPr>
@@ -5077,7 +5077,7 @@
           <p:cNvPr id="31" name="">
             <a:extLst xmlns:a="http://schemas.openxmlformats.org/drawingml/2006/main">
               <a:ext uri="{FF2B5EF4-FFF2-40B4-BE49-F238E27FC236}">
-                <a16:creationId xmlns:a16="http://schemas.microsoft.com/office/drawing/2014/main" id="{28A481A4-B37E-41DC-82BB-C000568E8E24}"/>
+                <a16:creationId xmlns:a16="http://schemas.microsoft.com/office/drawing/2014/main" id="{2BE86574-17F5-4A80-A3DB-4C4C79AD98B6}"/>
               </a:ext>
             </a:extLst>
           </p:cNvPr>
@@ -5145,7 +5145,7 @@
           <p:cNvPr id="2" name="">
             <a:extLst xmlns:a="http://schemas.openxmlformats.org/drawingml/2006/main">
               <a:ext uri="{FF2B5EF4-FFF2-40B4-BE49-F238E27FC236}">
-                <a16:creationId xmlns:a16="http://schemas.microsoft.com/office/drawing/2014/main" id="{0B5EEF8C-1BA3-4177-8616-27B3E6395B0E}"/>
+                <a16:creationId xmlns:a16="http://schemas.microsoft.com/office/drawing/2014/main" id="{FAB41EB0-A134-427F-9A13-1F51B36763F2}"/>
               </a:ext>
             </a:extLst>
           </p:cNvPr>
@@ -5213,7 +5213,7 @@
           <p:cNvPr id="3" name="">
             <a:extLst xmlns:a="http://schemas.openxmlformats.org/drawingml/2006/main">
               <a:ext uri="{FF2B5EF4-FFF2-40B4-BE49-F238E27FC236}">
-                <a16:creationId xmlns:a16="http://schemas.microsoft.com/office/drawing/2014/main" id="{D2BB110E-ED13-4680-B149-510648B61F37}"/>
+                <a16:creationId xmlns:a16="http://schemas.microsoft.com/office/drawing/2014/main" id="{0B6CE5E2-ABF9-4D34-9E29-EEFA7F66BF23}"/>
               </a:ext>
             </a:extLst>
           </p:cNvPr>
@@ -5281,7 +5281,7 @@
           <p:cNvPr id="4" name="">
             <a:extLst xmlns:a="http://schemas.openxmlformats.org/drawingml/2006/main">
               <a:ext uri="{FF2B5EF4-FFF2-40B4-BE49-F238E27FC236}">
-                <a16:creationId xmlns:a16="http://schemas.microsoft.com/office/drawing/2014/main" id="{690F5046-AFED-4D1E-B07E-7C31582BE21E}"/>
+                <a16:creationId xmlns:a16="http://schemas.microsoft.com/office/drawing/2014/main" id="{D6346AF1-ACC4-4058-8F43-2D9E8EF0CAEE}"/>
               </a:ext>
             </a:extLst>
           </p:cNvPr>
@@ -5313,7 +5313,7 @@
           <p:cNvPr id="5" name="">
             <a:extLst xmlns:a="http://schemas.openxmlformats.org/drawingml/2006/main">
               <a:ext uri="{FF2B5EF4-FFF2-40B4-BE49-F238E27FC236}">
-                <a16:creationId xmlns:a16="http://schemas.microsoft.com/office/drawing/2014/main" id="{9D2E0049-82EF-40BA-929E-684CC4936D72}"/>
+                <a16:creationId xmlns:a16="http://schemas.microsoft.com/office/drawing/2014/main" id="{E25541E6-28DC-4E47-B7DB-F75E41A49B3D}"/>
               </a:ext>
             </a:extLst>
           </p:cNvPr>
@@ -5381,7 +5381,7 @@
           <p:cNvPr id="6" name="">
             <a:extLst xmlns:a="http://schemas.openxmlformats.org/drawingml/2006/main">
               <a:ext uri="{FF2B5EF4-FFF2-40B4-BE49-F238E27FC236}">
-                <a16:creationId xmlns:a16="http://schemas.microsoft.com/office/drawing/2014/main" id="{D2EC5ED8-DD7E-4064-94D1-90D66BA3AE37}"/>
+                <a16:creationId xmlns:a16="http://schemas.microsoft.com/office/drawing/2014/main" id="{93A1178D-2F77-4422-AAEF-C2DBBCD7E969}"/>
               </a:ext>
             </a:extLst>
           </p:cNvPr>
@@ -5449,7 +5449,7 @@
           <p:cNvPr id="7" name="">
             <a:extLst xmlns:a="http://schemas.openxmlformats.org/drawingml/2006/main">
               <a:ext uri="{FF2B5EF4-FFF2-40B4-BE49-F238E27FC236}">
-                <a16:creationId xmlns:a16="http://schemas.microsoft.com/office/drawing/2014/main" id="{1909A785-6262-4506-A1E5-15715F86EC22}"/>
+                <a16:creationId xmlns:a16="http://schemas.microsoft.com/office/drawing/2014/main" id="{638AAB90-CB45-4A81-965F-42D7E2C0F6FE}"/>
               </a:ext>
             </a:extLst>
           </p:cNvPr>
@@ -5481,7 +5481,7 @@
           <p:cNvPr id="8" name="">
             <a:extLst xmlns:a="http://schemas.openxmlformats.org/drawingml/2006/main">
               <a:ext uri="{FF2B5EF4-FFF2-40B4-BE49-F238E27FC236}">
-                <a16:creationId xmlns:a16="http://schemas.microsoft.com/office/drawing/2014/main" id="{DA0B02D8-BB0A-4822-A33B-79002C375D17}"/>
+                <a16:creationId xmlns:a16="http://schemas.microsoft.com/office/drawing/2014/main" id="{71FA020B-2F44-4731-AE5C-A6FABB7A3812}"/>
               </a:ext>
             </a:extLst>
           </p:cNvPr>
@@ -5549,7 +5549,7 @@
           <p:cNvPr id="9" name="">
             <a:extLst xmlns:a="http://schemas.openxmlformats.org/drawingml/2006/main">
               <a:ext uri="{FF2B5EF4-FFF2-40B4-BE49-F238E27FC236}">
-                <a16:creationId xmlns:a16="http://schemas.microsoft.com/office/drawing/2014/main" id="{363C9532-680A-4FFD-9C13-40489CA06B77}"/>
+                <a16:creationId xmlns:a16="http://schemas.microsoft.com/office/drawing/2014/main" id="{B56CD7C3-FF96-42B0-ABCD-B4A264631C87}"/>
               </a:ext>
             </a:extLst>
           </p:cNvPr>
@@ -5617,7 +5617,7 @@
           <p:cNvPr id="11" name="">
             <a:extLst xmlns:a="http://schemas.openxmlformats.org/drawingml/2006/main">
               <a:ext uri="{FF2B5EF4-FFF2-40B4-BE49-F238E27FC236}">
-                <a16:creationId xmlns:a16="http://schemas.microsoft.com/office/drawing/2014/main" id="{635B2F98-9389-4BAF-AD4D-ADB2F9E3EB72}"/>
+                <a16:creationId xmlns:a16="http://schemas.microsoft.com/office/drawing/2014/main" id="{E4427137-5E16-45A8-8286-84DBBEDDCB94}"/>
               </a:ext>
             </a:extLst>
           </p:cNvPr>
@@ -5685,7 +5685,7 @@
           <p:cNvPr id="12" name="">
             <a:extLst xmlns:a="http://schemas.openxmlformats.org/drawingml/2006/main">
               <a:ext uri="{FF2B5EF4-FFF2-40B4-BE49-F238E27FC236}">
-                <a16:creationId xmlns:a16="http://schemas.microsoft.com/office/drawing/2014/main" id="{48F77292-B0E3-47DB-BCCB-90923722007C}"/>
+                <a16:creationId xmlns:a16="http://schemas.microsoft.com/office/drawing/2014/main" id="{7600E4F3-B5A0-40CC-87E6-C3636168C0DE}"/>
               </a:ext>
             </a:extLst>
           </p:cNvPr>
@@ -5717,7 +5717,7 @@
           <p:cNvPr id="13" name="">
             <a:extLst xmlns:a="http://schemas.openxmlformats.org/drawingml/2006/main">
               <a:ext uri="{FF2B5EF4-FFF2-40B4-BE49-F238E27FC236}">
-                <a16:creationId xmlns:a16="http://schemas.microsoft.com/office/drawing/2014/main" id="{61D24C34-DA77-4CA4-9A89-96E02AEDEFCE}"/>
+                <a16:creationId xmlns:a16="http://schemas.microsoft.com/office/drawing/2014/main" id="{17766B50-32BC-4425-A639-D5FEFEE7345E}"/>
               </a:ext>
             </a:extLst>
           </p:cNvPr>
@@ -5785,7 +5785,7 @@
           <p:cNvPr id="14" name="">
             <a:extLst xmlns:a="http://schemas.openxmlformats.org/drawingml/2006/main">
               <a:ext uri="{FF2B5EF4-FFF2-40B4-BE49-F238E27FC236}">
-                <a16:creationId xmlns:a16="http://schemas.microsoft.com/office/drawing/2014/main" id="{FB23813F-26FB-46B2-9DAD-C574A0808857}"/>
+                <a16:creationId xmlns:a16="http://schemas.microsoft.com/office/drawing/2014/main" id="{D70FD238-D160-47FB-A925-54EFE7FF5C63}"/>
               </a:ext>
             </a:extLst>
           </p:cNvPr>
@@ -5853,7 +5853,7 @@
           <p:cNvPr id="15" name="">
             <a:extLst xmlns:a="http://schemas.openxmlformats.org/drawingml/2006/main">
               <a:ext uri="{FF2B5EF4-FFF2-40B4-BE49-F238E27FC236}">
-                <a16:creationId xmlns:a16="http://schemas.microsoft.com/office/drawing/2014/main" id="{9986A443-BC13-4E31-9E20-5FC78F37F0F3}"/>
+                <a16:creationId xmlns:a16="http://schemas.microsoft.com/office/drawing/2014/main" id="{40DC4B2A-0EB5-456A-8183-21D4ED436B71}"/>
               </a:ext>
             </a:extLst>
           </p:cNvPr>
@@ -5885,7 +5885,7 @@
           <p:cNvPr id="16" name="">
             <a:extLst xmlns:a="http://schemas.openxmlformats.org/drawingml/2006/main">
               <a:ext uri="{FF2B5EF4-FFF2-40B4-BE49-F238E27FC236}">
-                <a16:creationId xmlns:a16="http://schemas.microsoft.com/office/drawing/2014/main" id="{3BAC924A-0D2C-493F-8D80-C0A85F8B1A8C}"/>
+                <a16:creationId xmlns:a16="http://schemas.microsoft.com/office/drawing/2014/main" id="{E72BB568-018B-42A4-8941-E9CE2916B390}"/>
               </a:ext>
             </a:extLst>
           </p:cNvPr>
@@ -5953,7 +5953,7 @@
           <p:cNvPr id="17" name="">
             <a:extLst xmlns:a="http://schemas.openxmlformats.org/drawingml/2006/main">
               <a:ext uri="{FF2B5EF4-FFF2-40B4-BE49-F238E27FC236}">
-                <a16:creationId xmlns:a16="http://schemas.microsoft.com/office/drawing/2014/main" id="{546DA14B-FA71-4E68-A33F-8AE4062A73BC}"/>
+                <a16:creationId xmlns:a16="http://schemas.microsoft.com/office/drawing/2014/main" id="{C745DEF5-565E-44C6-A412-1C81682BCE66}"/>
               </a:ext>
             </a:extLst>
           </p:cNvPr>
@@ -6021,7 +6021,7 @@
           <p:cNvPr id="18" name="">
             <a:extLst xmlns:a="http://schemas.openxmlformats.org/drawingml/2006/main">
               <a:ext uri="{FF2B5EF4-FFF2-40B4-BE49-F238E27FC236}">
-                <a16:creationId xmlns:a16="http://schemas.microsoft.com/office/drawing/2014/main" id="{90774CD1-159D-47C6-BFB3-3FC6E2E59BDC}"/>
+                <a16:creationId xmlns:a16="http://schemas.microsoft.com/office/drawing/2014/main" id="{88BBE50F-D6F7-4A60-ABAA-7AA35ED68F47}"/>
               </a:ext>
             </a:extLst>
           </p:cNvPr>
@@ -6053,7 +6053,7 @@
           <p:cNvPr id="19" name="">
             <a:extLst xmlns:a="http://schemas.openxmlformats.org/drawingml/2006/main">
               <a:ext uri="{FF2B5EF4-FFF2-40B4-BE49-F238E27FC236}">
-                <a16:creationId xmlns:a16="http://schemas.microsoft.com/office/drawing/2014/main" id="{91C03C34-8B30-4BCA-9241-631DF29A49D8}"/>
+                <a16:creationId xmlns:a16="http://schemas.microsoft.com/office/drawing/2014/main" id="{02D3BB5C-C26A-4B98-8595-88D43BB3AFBA}"/>
               </a:ext>
             </a:extLst>
           </p:cNvPr>
@@ -6121,7 +6121,7 @@
           <p:cNvPr id="20" name="">
             <a:extLst xmlns:a="http://schemas.openxmlformats.org/drawingml/2006/main">
               <a:ext uri="{FF2B5EF4-FFF2-40B4-BE49-F238E27FC236}">
-                <a16:creationId xmlns:a16="http://schemas.microsoft.com/office/drawing/2014/main" id="{2B404CD6-D322-439B-9AB6-476BBF44E1AE}"/>
+                <a16:creationId xmlns:a16="http://schemas.microsoft.com/office/drawing/2014/main" id="{4104ED02-04FF-4767-8CE7-1153E2F62D12}"/>
               </a:ext>
             </a:extLst>
           </p:cNvPr>
@@ -6189,7 +6189,7 @@
           <p:cNvPr id="24" name="">
             <a:extLst xmlns:a="http://schemas.openxmlformats.org/drawingml/2006/main">
               <a:ext uri="{FF2B5EF4-FFF2-40B4-BE49-F238E27FC236}">
-                <a16:creationId xmlns:a16="http://schemas.microsoft.com/office/drawing/2014/main" id="{7BE90C30-9578-4C24-8222-2C96147989C4}"/>
+                <a16:creationId xmlns:a16="http://schemas.microsoft.com/office/drawing/2014/main" id="{7D3554ED-97EB-40BC-BD0A-1FD5EE096549}"/>
               </a:ext>
             </a:extLst>
           </p:cNvPr>
@@ -6221,7 +6221,7 @@
           <p:cNvPr id="25" name="">
             <a:extLst xmlns:a="http://schemas.openxmlformats.org/drawingml/2006/main">
               <a:ext uri="{FF2B5EF4-FFF2-40B4-BE49-F238E27FC236}">
-                <a16:creationId xmlns:a16="http://schemas.microsoft.com/office/drawing/2014/main" id="{A34D4A58-C587-4A47-A300-571605F9B57C}"/>
+                <a16:creationId xmlns:a16="http://schemas.microsoft.com/office/drawing/2014/main" id="{B1BD90F0-D140-4101-91DD-A0BDDCB37240}"/>
               </a:ext>
             </a:extLst>
           </p:cNvPr>
@@ -6289,7 +6289,7 @@
           <p:cNvPr id="26" name="">
             <a:extLst xmlns:a="http://schemas.openxmlformats.org/drawingml/2006/main">
               <a:ext uri="{FF2B5EF4-FFF2-40B4-BE49-F238E27FC236}">
-                <a16:creationId xmlns:a16="http://schemas.microsoft.com/office/drawing/2014/main" id="{5E5F013D-085D-4AFB-A683-AC98E660E888}"/>
+                <a16:creationId xmlns:a16="http://schemas.microsoft.com/office/drawing/2014/main" id="{3AE395F2-F727-4492-9EA4-F6E32CD0CB84}"/>
               </a:ext>
             </a:extLst>
           </p:cNvPr>
@@ -6357,7 +6357,7 @@
           <p:cNvPr id="28" name="">
             <a:extLst xmlns:a="http://schemas.openxmlformats.org/drawingml/2006/main">
               <a:ext uri="{FF2B5EF4-FFF2-40B4-BE49-F238E27FC236}">
-                <a16:creationId xmlns:a16="http://schemas.microsoft.com/office/drawing/2014/main" id="{EBDE3F11-4E17-488C-B49E-30639105721C}"/>
+                <a16:creationId xmlns:a16="http://schemas.microsoft.com/office/drawing/2014/main" id="{C74013D5-81A1-4B2F-89CF-6DF691A86C59}"/>
               </a:ext>
             </a:extLst>
           </p:cNvPr>
@@ -6425,7 +6425,7 @@
           <p:cNvPr id="29" name="">
             <a:extLst xmlns:a="http://schemas.openxmlformats.org/drawingml/2006/main">
               <a:ext uri="{FF2B5EF4-FFF2-40B4-BE49-F238E27FC236}">
-                <a16:creationId xmlns:a16="http://schemas.microsoft.com/office/drawing/2014/main" id="{38932564-11FE-49AB-B403-10171876C224}"/>
+                <a16:creationId xmlns:a16="http://schemas.microsoft.com/office/drawing/2014/main" id="{E40F862C-8344-4216-98B0-59F05A5223E8}"/>
               </a:ext>
             </a:extLst>
           </p:cNvPr>
@@ -6493,7 +6493,7 @@
           <p:cNvPr id="30" name="">
             <a:extLst xmlns:a="http://schemas.openxmlformats.org/drawingml/2006/main">
               <a:ext uri="{FF2B5EF4-FFF2-40B4-BE49-F238E27FC236}">
-                <a16:creationId xmlns:a16="http://schemas.microsoft.com/office/drawing/2014/main" id="{27154CBD-7941-44AA-A468-D371EE03DCEC}"/>
+                <a16:creationId xmlns:a16="http://schemas.microsoft.com/office/drawing/2014/main" id="{310F41DF-88E6-4E65-AA54-6FE533315D34}"/>
               </a:ext>
             </a:extLst>
           </p:cNvPr>
@@ -6559,7 +6559,7 @@
     </p:spTree>
     <p:extLst>
       <p:ext uri="{BB962C8B-B14F-4D97-AF65-F5344CB8AC3E}">
-        <p14:creationId xmlns:p14="http://schemas.microsoft.com/office/powerpoint/2010/main" val="1040077181"/>
+        <p14:creationId xmlns:p14="http://schemas.microsoft.com/office/powerpoint/2010/main" val="22556657"/>
       </p:ext>
     </p:extLst>
   </p:cSld>
@@ -6590,7 +6590,7 @@
           <p:cNvPr id="14" name="">
             <a:extLst xmlns:a="http://schemas.openxmlformats.org/drawingml/2006/main">
               <a:ext uri="{FF2B5EF4-FFF2-40B4-BE49-F238E27FC236}">
-                <a16:creationId xmlns:a16="http://schemas.microsoft.com/office/drawing/2014/main" id="{87882B01-7B23-45D3-8A02-D8C55971E648}"/>
+                <a16:creationId xmlns:a16="http://schemas.microsoft.com/office/drawing/2014/main" id="{8EDDC317-9A54-446D-BD73-538F8B2DA016}"/>
               </a:ext>
             </a:extLst>
           </p:cNvPr>
@@ -6610,9 +6610,9 @@
           </a:prstGeom>
           <a:ln xmlns:a="http://schemas.openxmlformats.org/drawingml/2006/main" w="19050">
             <a:solidFill>
-              <a:srgbClr val="B6601E"/>
+              <a:srgbClr val="087E70"/>
             </a:solidFill>
-            <a:prstDash val="dash"/>
+            <a:prstDash val="solid"/>
             <a:tailEnd type="triangle" w="med" len="med"/>
           </a:ln>
         </p:spPr>
@@ -6622,7 +6622,7 @@
           <p:cNvPr id="13" name="">
             <a:extLst xmlns:a="http://schemas.openxmlformats.org/drawingml/2006/main">
               <a:ext uri="{FF2B5EF4-FFF2-40B4-BE49-F238E27FC236}">
-                <a16:creationId xmlns:a16="http://schemas.microsoft.com/office/drawing/2014/main" id="{0C9278CF-8002-49F2-8208-F0C59AD0D1EC}"/>
+                <a16:creationId xmlns:a16="http://schemas.microsoft.com/office/drawing/2014/main" id="{BDE56E7A-FA0A-4383-8B8F-69C7BA3A9C2F}"/>
               </a:ext>
             </a:extLst>
           </p:cNvPr>
@@ -6642,9 +6642,9 @@
           </a:prstGeom>
           <a:ln xmlns:a="http://schemas.openxmlformats.org/drawingml/2006/main" w="19050">
             <a:solidFill>
-              <a:srgbClr val="B6601E"/>
+              <a:srgbClr val="087E70"/>
             </a:solidFill>
-            <a:prstDash val="dash"/>
+            <a:prstDash val="solid"/>
             <a:tailEnd type="triangle" w="med" len="med"/>
           </a:ln>
         </p:spPr>
@@ -6654,7 +6654,7 @@
           <p:cNvPr id="18" name="">
             <a:extLst xmlns:a="http://schemas.openxmlformats.org/drawingml/2006/main">
               <a:ext uri="{FF2B5EF4-FFF2-40B4-BE49-F238E27FC236}">
-                <a16:creationId xmlns:a16="http://schemas.microsoft.com/office/drawing/2014/main" id="{7E04CEEE-C942-4F48-BE40-846EFFCB4412}"/>
+                <a16:creationId xmlns:a16="http://schemas.microsoft.com/office/drawing/2014/main" id="{2AEF3D70-9447-4BF0-93F2-4336AC740957}"/>
               </a:ext>
             </a:extLst>
           </p:cNvPr>
@@ -6712,7 +6712,7 @@
                 <a:ea typeface="Arial"/>
                 <a:cs typeface="Arial"/>
               </a:rPr>
-              <a:t>AWS midpoint deployment plan</a:t>
+              <a:t>Verified AWS midpoint deployment</a:t>
             </a:r>
           </a:p>
         </p:txBody>
@@ -6722,7 +6722,7 @@
           <p:cNvPr id="2" name="">
             <a:extLst xmlns:a="http://schemas.openxmlformats.org/drawingml/2006/main">
               <a:ext uri="{FF2B5EF4-FFF2-40B4-BE49-F238E27FC236}">
-                <a16:creationId xmlns:a16="http://schemas.microsoft.com/office/drawing/2014/main" id="{5BCDE387-82BD-4EDD-B93E-F5D571AABA73}"/>
+                <a16:creationId xmlns:a16="http://schemas.microsoft.com/office/drawing/2014/main" id="{BCAFC17C-0CD7-48C5-B343-CE80AB7EFBAB}"/>
               </a:ext>
             </a:extLst>
           </p:cNvPr>
@@ -6790,7 +6790,7 @@
           <p:cNvPr id="3" name="">
             <a:extLst xmlns:a="http://schemas.openxmlformats.org/drawingml/2006/main">
               <a:ext uri="{FF2B5EF4-FFF2-40B4-BE49-F238E27FC236}">
-                <a16:creationId xmlns:a16="http://schemas.microsoft.com/office/drawing/2014/main" id="{4016ED34-1E3A-4BAF-8C8E-D0E685967BB1}"/>
+                <a16:creationId xmlns:a16="http://schemas.microsoft.com/office/drawing/2014/main" id="{A6E3F275-C4AA-46CF-8E9B-88415FB949AF}"/>
               </a:ext>
             </a:extLst>
           </p:cNvPr>
@@ -6820,7 +6820,7 @@
             <a:defPPr>
               <a:defRPr sz="1800" b="1">
                 <a:solidFill>
-                  <a:srgbClr val="B6601E"/>
+                  <a:srgbClr val="087E70"/>
                 </a:solidFill>
                 <a:latin typeface="Arial"/>
                 <a:ea typeface="Arial"/>
@@ -6832,7 +6832,7 @@
             <a:pPr>
               <a:defRPr sz="1800" b="1">
                 <a:solidFill>
-                  <a:srgbClr val="B6601E"/>
+                  <a:srgbClr val="087E70"/>
                 </a:solidFill>
                 <a:latin typeface="Arial"/>
                 <a:ea typeface="Arial"/>
@@ -6842,13 +6842,13 @@
             <a:r>
               <a:rPr sz="1800" b="1">
                 <a:solidFill>
-                  <a:srgbClr val="B6601E"/>
+                  <a:srgbClr val="087E70"/>
                 </a:solidFill>
                 <a:latin typeface="Arial"/>
                 <a:ea typeface="Arial"/>
                 <a:cs typeface="Arial"/>
               </a:rPr>
-              <a:t>PLANNED — awaiting launch and inference verification</a:t>
+              <a:t>Qwen model response and native metrics verified on EC2</a:t>
             </a:r>
           </a:p>
         </p:txBody>
@@ -6858,7 +6858,7 @@
           <p:cNvPr id="4" name="">
             <a:extLst xmlns:a="http://schemas.openxmlformats.org/drawingml/2006/main">
               <a:ext uri="{FF2B5EF4-FFF2-40B4-BE49-F238E27FC236}">
-                <a16:creationId xmlns:a16="http://schemas.microsoft.com/office/drawing/2014/main" id="{D65173D0-210C-4EDB-A61E-5614F023B001}"/>
+                <a16:creationId xmlns:a16="http://schemas.microsoft.com/office/drawing/2014/main" id="{0483EA66-759C-4A5C-811B-30879C59A3FF}"/>
               </a:ext>
             </a:extLst>
           </p:cNvPr>
@@ -6876,11 +6876,11 @@
             <a:avLst/>
           </a:prstGeom>
           <a:solidFill xmlns:a="http://schemas.openxmlformats.org/drawingml/2006/main">
-            <a:srgbClr val="FFF1DE"/>
+            <a:srgbClr val="E7F3EF"/>
           </a:solidFill>
           <a:ln xmlns:a="http://schemas.openxmlformats.org/drawingml/2006/main" w="9525">
             <a:solidFill>
-              <a:srgbClr val="B6601E"/>
+              <a:srgbClr val="087E70"/>
             </a:solidFill>
           </a:ln>
         </p:spPr>
@@ -6890,7 +6890,7 @@
           <p:cNvPr id="5" name="">
             <a:extLst xmlns:a="http://schemas.openxmlformats.org/drawingml/2006/main">
               <a:ext uri="{FF2B5EF4-FFF2-40B4-BE49-F238E27FC236}">
-                <a16:creationId xmlns:a16="http://schemas.microsoft.com/office/drawing/2014/main" id="{0920F1FE-0496-4F7E-BCBE-18CFB9B8C4F8}"/>
+                <a16:creationId xmlns:a16="http://schemas.microsoft.com/office/drawing/2014/main" id="{1C252C6A-8499-4AD5-8243-114909FDAD74}"/>
               </a:ext>
             </a:extLst>
           </p:cNvPr>
@@ -6958,7 +6958,7 @@
           <p:cNvPr id="6" name="">
             <a:extLst xmlns:a="http://schemas.openxmlformats.org/drawingml/2006/main">
               <a:ext uri="{FF2B5EF4-FFF2-40B4-BE49-F238E27FC236}">
-                <a16:creationId xmlns:a16="http://schemas.microsoft.com/office/drawing/2014/main" id="{7FF9EDC5-1C2F-4C01-A4A3-0FBB41E90F92}"/>
+                <a16:creationId xmlns:a16="http://schemas.microsoft.com/office/drawing/2014/main" id="{ADCCDDBB-F377-4709-96D7-97D74B37918A}"/>
               </a:ext>
             </a:extLst>
           </p:cNvPr>
@@ -7016,7 +7016,7 @@
                 <a:ea typeface="Arial"/>
                 <a:cs typeface="Arial"/>
               </a:rPr>
-              <a:t>Restricted inbound access</a:t>
+              <a:t>/32 access on TCP 8000</a:t>
             </a:r>
           </a:p>
         </p:txBody>
@@ -7026,7 +7026,7 @@
           <p:cNvPr id="7" name="">
             <a:extLst xmlns:a="http://schemas.openxmlformats.org/drawingml/2006/main">
               <a:ext uri="{FF2B5EF4-FFF2-40B4-BE49-F238E27FC236}">
-                <a16:creationId xmlns:a16="http://schemas.microsoft.com/office/drawing/2014/main" id="{E912216C-4E2D-4A3A-BE62-35DE7D502C64}"/>
+                <a16:creationId xmlns:a16="http://schemas.microsoft.com/office/drawing/2014/main" id="{BF5BFC49-73CA-406E-A6ED-AB9B5A344595}"/>
               </a:ext>
             </a:extLst>
           </p:cNvPr>
@@ -7044,11 +7044,11 @@
             <a:avLst/>
           </a:prstGeom>
           <a:solidFill xmlns:a="http://schemas.openxmlformats.org/drawingml/2006/main">
-            <a:srgbClr val="FFF1DE"/>
+            <a:srgbClr val="E7F3EF"/>
           </a:solidFill>
           <a:ln xmlns:a="http://schemas.openxmlformats.org/drawingml/2006/main" w="9525">
             <a:solidFill>
-              <a:srgbClr val="B6601E"/>
+              <a:srgbClr val="087E70"/>
             </a:solidFill>
           </a:ln>
         </p:spPr>
@@ -7058,7 +7058,7 @@
           <p:cNvPr id="8" name="">
             <a:extLst xmlns:a="http://schemas.openxmlformats.org/drawingml/2006/main">
               <a:ext uri="{FF2B5EF4-FFF2-40B4-BE49-F238E27FC236}">
-                <a16:creationId xmlns:a16="http://schemas.microsoft.com/office/drawing/2014/main" id="{94A287A4-F634-4891-BB79-E8A00316C8AB}"/>
+                <a16:creationId xmlns:a16="http://schemas.microsoft.com/office/drawing/2014/main" id="{BC86792E-46B4-4D98-A0C4-DDB955717DEF}"/>
               </a:ext>
             </a:extLst>
           </p:cNvPr>
@@ -7116,7 +7116,7 @@
                 <a:ea typeface="Arial"/>
                 <a:cs typeface="Arial"/>
               </a:rPr>
-              <a:t>EC2 in a public subnet</a:t>
+              <a:t>EC2: t3.small + Docker</a:t>
             </a:r>
           </a:p>
         </p:txBody>
@@ -7126,7 +7126,7 @@
           <p:cNvPr id="9" name="">
             <a:extLst xmlns:a="http://schemas.openxmlformats.org/drawingml/2006/main">
               <a:ext uri="{FF2B5EF4-FFF2-40B4-BE49-F238E27FC236}">
-                <a16:creationId xmlns:a16="http://schemas.microsoft.com/office/drawing/2014/main" id="{01D8545A-1BA2-4643-B084-F440883F2CCB}"/>
+                <a16:creationId xmlns:a16="http://schemas.microsoft.com/office/drawing/2014/main" id="{733D3E1B-3755-480B-B402-3D495F35BF12}"/>
               </a:ext>
             </a:extLst>
           </p:cNvPr>
@@ -7184,7 +7184,7 @@
                 <a:ea typeface="Arial"/>
                 <a:cs typeface="Arial"/>
               </a:rPr>
-              <a:t>Permitted t3 instance + Docker</a:t>
+              <a:t>1 GiB container, 2 CPU limit</a:t>
             </a:r>
           </a:p>
         </p:txBody>
@@ -7194,7 +7194,7 @@
           <p:cNvPr id="10" name="">
             <a:extLst xmlns:a="http://schemas.openxmlformats.org/drawingml/2006/main">
               <a:ext uri="{FF2B5EF4-FFF2-40B4-BE49-F238E27FC236}">
-                <a16:creationId xmlns:a16="http://schemas.microsoft.com/office/drawing/2014/main" id="{E137A82C-CBB9-4776-B2ED-0FBD6805359F}"/>
+                <a16:creationId xmlns:a16="http://schemas.microsoft.com/office/drawing/2014/main" id="{F6DC9523-F275-40D4-8B92-2EC667E7BD7A}"/>
               </a:ext>
             </a:extLst>
           </p:cNvPr>
@@ -7212,11 +7212,11 @@
             <a:avLst/>
           </a:prstGeom>
           <a:solidFill xmlns:a="http://schemas.openxmlformats.org/drawingml/2006/main">
-            <a:srgbClr val="FFF1DE"/>
+            <a:srgbClr val="E7F3EF"/>
           </a:solidFill>
           <a:ln xmlns:a="http://schemas.openxmlformats.org/drawingml/2006/main" w="9525">
             <a:solidFill>
-              <a:srgbClr val="B6601E"/>
+              <a:srgbClr val="087E70"/>
             </a:solidFill>
           </a:ln>
         </p:spPr>
@@ -7226,7 +7226,7 @@
           <p:cNvPr id="11" name="">
             <a:extLst xmlns:a="http://schemas.openxmlformats.org/drawingml/2006/main">
               <a:ext uri="{FF2B5EF4-FFF2-40B4-BE49-F238E27FC236}">
-                <a16:creationId xmlns:a16="http://schemas.microsoft.com/office/drawing/2014/main" id="{D90BD839-C5A7-466E-98CA-BD79A2176934}"/>
+                <a16:creationId xmlns:a16="http://schemas.microsoft.com/office/drawing/2014/main" id="{7E1F6EC3-CAAA-4E28-B186-944604481B76}"/>
               </a:ext>
             </a:extLst>
           </p:cNvPr>
@@ -7294,7 +7294,7 @@
           <p:cNvPr id="12" name="">
             <a:extLst xmlns:a="http://schemas.openxmlformats.org/drawingml/2006/main">
               <a:ext uri="{FF2B5EF4-FFF2-40B4-BE49-F238E27FC236}">
-                <a16:creationId xmlns:a16="http://schemas.microsoft.com/office/drawing/2014/main" id="{A0259F39-527B-4ED9-9DC9-4BAFD1B88B8D}"/>
+                <a16:creationId xmlns:a16="http://schemas.microsoft.com/office/drawing/2014/main" id="{63CB8B7A-D65E-4624-9693-DF027CD9EEAE}"/>
               </a:ext>
             </a:extLst>
           </p:cNvPr>
@@ -7352,7 +7352,7 @@
                 <a:ea typeface="Arial"/>
                 <a:cs typeface="Arial"/>
               </a:rPr>
-              <a:t>gp2 model cache</a:t>
+              <a:t>20 GiB gp2 model cache</a:t>
             </a:r>
           </a:p>
         </p:txBody>
@@ -7362,7 +7362,7 @@
           <p:cNvPr id="15" name="">
             <a:extLst xmlns:a="http://schemas.openxmlformats.org/drawingml/2006/main">
               <a:ext uri="{FF2B5EF4-FFF2-40B4-BE49-F238E27FC236}">
-                <a16:creationId xmlns:a16="http://schemas.microsoft.com/office/drawing/2014/main" id="{E6112873-4715-4C61-A341-0ABED82F7041}"/>
+                <a16:creationId xmlns:a16="http://schemas.microsoft.com/office/drawing/2014/main" id="{7A3AFE19-5EE8-42D2-A51E-906CB5C2A8A6}"/>
               </a:ext>
             </a:extLst>
           </p:cNvPr>
@@ -7374,7 +7374,7 @@
         <p:spPr>
           <a:xfrm xmlns:a="http://schemas.openxmlformats.org/drawingml/2006/main">
             <a:off x="3714750" y="4076700"/>
-            <a:ext cx="6667500" cy="400050"/>
+            <a:ext cx="7810500" cy="400050"/>
           </a:xfrm>
           <a:prstGeom xmlns:a="http://schemas.openxmlformats.org/drawingml/2006/main" prst="rect">
             <a:avLst/>
@@ -7420,7 +7420,7 @@
                 <a:ea typeface="Arial"/>
                 <a:cs typeface="Arial"/>
               </a:rPr>
-              <a:t>VPC, route table and internet gateway</a:t>
+              <a:t>Existing VPC, subnet, route and internet gateway</a:t>
             </a:r>
           </a:p>
         </p:txBody>
@@ -7430,7 +7430,7 @@
           <p:cNvPr id="16" name="">
             <a:extLst xmlns:a="http://schemas.openxmlformats.org/drawingml/2006/main">
               <a:ext uri="{FF2B5EF4-FFF2-40B4-BE49-F238E27FC236}">
-                <a16:creationId xmlns:a16="http://schemas.microsoft.com/office/drawing/2014/main" id="{D8F7BF60-C5FA-44DB-AD93-2BAD52B45845}"/>
+                <a16:creationId xmlns:a16="http://schemas.microsoft.com/office/drawing/2014/main" id="{34072B58-EDCD-4F58-8564-B3DCF044A88E}"/>
               </a:ext>
             </a:extLst>
           </p:cNvPr>
@@ -7488,7 +7488,7 @@
                 <a:ea typeface="Arial"/>
                 <a:cs typeface="Arial"/>
               </a:rPr>
-              <a:t>Public image pull from GHCR</a:t>
+              <a:t>Real inference: HTTP 200, 34 output tokens</a:t>
             </a:r>
           </a:p>
           <a:p xmlns:a="http://schemas.openxmlformats.org/drawingml/2006/main">
@@ -7511,7 +7511,7 @@
                 <a:ea typeface="Arial"/>
                 <a:cs typeface="Arial"/>
               </a:rPr>
-              <a:t>Existing permitted IAM profile if available</a:t>
+              <a:t>One request: 2.30 s client time. Model load: 7.66 s.</a:t>
             </a:r>
           </a:p>
         </p:txBody>
@@ -7521,7 +7521,7 @@
           <p:cNvPr id="17" name="">
             <a:extLst xmlns:a="http://schemas.openxmlformats.org/drawingml/2006/main">
               <a:ext uri="{FF2B5EF4-FFF2-40B4-BE49-F238E27FC236}">
-                <a16:creationId xmlns:a16="http://schemas.microsoft.com/office/drawing/2014/main" id="{4AF9B85A-40BE-4506-9CE5-676B29C07EC0}"/>
+                <a16:creationId xmlns:a16="http://schemas.microsoft.com/office/drawing/2014/main" id="{2151D40F-3EDB-4C71-9536-D1A4ACB61383}"/>
               </a:ext>
             </a:extLst>
           </p:cNvPr>
@@ -7587,7 +7587,7 @@
     </p:spTree>
     <p:extLst>
       <p:ext uri="{BB962C8B-B14F-4D97-AF65-F5344CB8AC3E}">
-        <p14:creationId xmlns:p14="http://schemas.microsoft.com/office/powerpoint/2010/main" val="996138815"/>
+        <p14:creationId xmlns:p14="http://schemas.microsoft.com/office/powerpoint/2010/main" val="1967635075"/>
       </p:ext>
     </p:extLst>
   </p:cSld>
@@ -7618,7 +7618,7 @@
           <p:cNvPr id="13" name="">
             <a:extLst xmlns:a="http://schemas.openxmlformats.org/drawingml/2006/main">
               <a:ext uri="{FF2B5EF4-FFF2-40B4-BE49-F238E27FC236}">
-                <a16:creationId xmlns:a16="http://schemas.microsoft.com/office/drawing/2014/main" id="{08161AAE-128A-4F09-A945-E81B7D242FEA}"/>
+                <a16:creationId xmlns:a16="http://schemas.microsoft.com/office/drawing/2014/main" id="{488147E8-2832-4A37-A9A3-9F47910103D8}"/>
               </a:ext>
             </a:extLst>
           </p:cNvPr>
@@ -7686,7 +7686,7 @@
           <p:cNvPr id="2" name="">
             <a:extLst xmlns:a="http://schemas.openxmlformats.org/drawingml/2006/main">
               <a:ext uri="{FF2B5EF4-FFF2-40B4-BE49-F238E27FC236}">
-                <a16:creationId xmlns:a16="http://schemas.microsoft.com/office/drawing/2014/main" id="{EE548FE6-98B6-4F56-9878-2F024FB99AEF}"/>
+                <a16:creationId xmlns:a16="http://schemas.microsoft.com/office/drawing/2014/main" id="{226270D5-32CB-4150-BA92-7BE062AA947D}"/>
               </a:ext>
             </a:extLst>
           </p:cNvPr>
@@ -7754,7 +7754,7 @@
           <p:cNvPr id="3" name="">
             <a:extLst xmlns:a="http://schemas.openxmlformats.org/drawingml/2006/main">
               <a:ext uri="{FF2B5EF4-FFF2-40B4-BE49-F238E27FC236}">
-                <a16:creationId xmlns:a16="http://schemas.microsoft.com/office/drawing/2014/main" id="{099ED046-4C8E-4862-8CD2-D04D7271470F}"/>
+                <a16:creationId xmlns:a16="http://schemas.microsoft.com/office/drawing/2014/main" id="{2FCCD218-9E9F-49F5-B044-A053D2C815FD}"/>
               </a:ext>
             </a:extLst>
           </p:cNvPr>
@@ -7822,7 +7822,7 @@
           <p:cNvPr id="4" name="">
             <a:extLst xmlns:a="http://schemas.openxmlformats.org/drawingml/2006/main">
               <a:ext uri="{FF2B5EF4-FFF2-40B4-BE49-F238E27FC236}">
-                <a16:creationId xmlns:a16="http://schemas.microsoft.com/office/drawing/2014/main" id="{A21C3716-FD98-42BC-A204-12673A1F661E}"/>
+                <a16:creationId xmlns:a16="http://schemas.microsoft.com/office/drawing/2014/main" id="{027BBB87-0A95-421D-AC28-A2CDAB695FFC}"/>
               </a:ext>
             </a:extLst>
           </p:cNvPr>
@@ -7890,7 +7890,7 @@
           <p:cNvPr id="5" name="">
             <a:extLst xmlns:a="http://schemas.openxmlformats.org/drawingml/2006/main">
               <a:ext uri="{FF2B5EF4-FFF2-40B4-BE49-F238E27FC236}">
-                <a16:creationId xmlns:a16="http://schemas.microsoft.com/office/drawing/2014/main" id="{3A2744ED-9E0B-4E8D-9F4A-8E2356E83D78}"/>
+                <a16:creationId xmlns:a16="http://schemas.microsoft.com/office/drawing/2014/main" id="{3741C5D6-B325-42E1-B2D3-CA81B5BC4927}"/>
               </a:ext>
             </a:extLst>
           </p:cNvPr>
@@ -7958,7 +7958,7 @@
           <p:cNvPr id="6" name="">
             <a:extLst xmlns:a="http://schemas.openxmlformats.org/drawingml/2006/main">
               <a:ext uri="{FF2B5EF4-FFF2-40B4-BE49-F238E27FC236}">
-                <a16:creationId xmlns:a16="http://schemas.microsoft.com/office/drawing/2014/main" id="{DEF50002-1572-4F23-8A2E-5B6A0A4E20AA}"/>
+                <a16:creationId xmlns:a16="http://schemas.microsoft.com/office/drawing/2014/main" id="{F339B93B-F52C-4236-AE85-9C281CAA94F2}"/>
               </a:ext>
             </a:extLst>
           </p:cNvPr>
@@ -8026,7 +8026,7 @@
           <p:cNvPr id="7" name="">
             <a:extLst xmlns:a="http://schemas.openxmlformats.org/drawingml/2006/main">
               <a:ext uri="{FF2B5EF4-FFF2-40B4-BE49-F238E27FC236}">
-                <a16:creationId xmlns:a16="http://schemas.microsoft.com/office/drawing/2014/main" id="{1D83F6FC-E8D6-4892-B1D6-4C8FFEA61E6B}"/>
+                <a16:creationId xmlns:a16="http://schemas.microsoft.com/office/drawing/2014/main" id="{A0A6C549-F990-4143-A6FB-1F033CBC1E56}"/>
               </a:ext>
             </a:extLst>
           </p:cNvPr>
@@ -8084,7 +8084,7 @@
                 <a:ea typeface="Arial"/>
                 <a:cs typeface="Arial"/>
               </a:rPr>
-              <a:t>Terraform formatting and validation across six roots/modules.</a:t>
+              <a:t>Seven Terraform roots/modules and three mocked safety plans.</a:t>
             </a:r>
           </a:p>
         </p:txBody>
@@ -8094,7 +8094,7 @@
           <p:cNvPr id="8" name="">
             <a:extLst xmlns:a="http://schemas.openxmlformats.org/drawingml/2006/main">
               <a:ext uri="{FF2B5EF4-FFF2-40B4-BE49-F238E27FC236}">
-                <a16:creationId xmlns:a16="http://schemas.microsoft.com/office/drawing/2014/main" id="{8993454E-FD0A-4689-9241-4AAF93503428}"/>
+                <a16:creationId xmlns:a16="http://schemas.microsoft.com/office/drawing/2014/main" id="{679952E4-E20F-4C3A-9E14-3EE4A0072C21}"/>
               </a:ext>
             </a:extLst>
           </p:cNvPr>
@@ -8162,7 +8162,7 @@
           <p:cNvPr id="9" name="">
             <a:extLst xmlns:a="http://schemas.openxmlformats.org/drawingml/2006/main">
               <a:ext uri="{FF2B5EF4-FFF2-40B4-BE49-F238E27FC236}">
-                <a16:creationId xmlns:a16="http://schemas.microsoft.com/office/drawing/2014/main" id="{CFCF466B-2EB5-4372-8345-5341F626EE86}"/>
+                <a16:creationId xmlns:a16="http://schemas.microsoft.com/office/drawing/2014/main" id="{730DF39F-DD99-40C6-89A9-C764B1B1AC4E}"/>
               </a:ext>
             </a:extLst>
           </p:cNvPr>
@@ -8230,7 +8230,7 @@
           <p:cNvPr id="10" name="">
             <a:extLst xmlns:a="http://schemas.openxmlformats.org/drawingml/2006/main">
               <a:ext uri="{FF2B5EF4-FFF2-40B4-BE49-F238E27FC236}">
-                <a16:creationId xmlns:a16="http://schemas.microsoft.com/office/drawing/2014/main" id="{4DA86E36-E734-489E-B883-30688DE1224E}"/>
+                <a16:creationId xmlns:a16="http://schemas.microsoft.com/office/drawing/2014/main" id="{84E331C6-E163-42A2-9693-2572A30F7414}"/>
               </a:ext>
             </a:extLst>
           </p:cNvPr>
@@ -8298,7 +8298,7 @@
           <p:cNvPr id="11" name="">
             <a:extLst xmlns:a="http://schemas.openxmlformats.org/drawingml/2006/main">
               <a:ext uri="{FF2B5EF4-FFF2-40B4-BE49-F238E27FC236}">
-                <a16:creationId xmlns:a16="http://schemas.microsoft.com/office/drawing/2014/main" id="{B7300B51-6D25-429E-9F56-E43876569F46}"/>
+                <a16:creationId xmlns:a16="http://schemas.microsoft.com/office/drawing/2014/main" id="{4A712240-802C-4FD0-BD1D-5E5EB6B777AF}"/>
               </a:ext>
             </a:extLst>
           </p:cNvPr>
@@ -8366,7 +8366,7 @@
           <p:cNvPr id="12" name="">
             <a:extLst xmlns:a="http://schemas.openxmlformats.org/drawingml/2006/main">
               <a:ext uri="{FF2B5EF4-FFF2-40B4-BE49-F238E27FC236}">
-                <a16:creationId xmlns:a16="http://schemas.microsoft.com/office/drawing/2014/main" id="{C589F586-EB03-4CD6-9778-691D79782623}"/>
+                <a16:creationId xmlns:a16="http://schemas.microsoft.com/office/drawing/2014/main" id="{C26BAC10-E56B-43A9-8A68-D803F5672686}"/>
               </a:ext>
             </a:extLst>
           </p:cNvPr>
@@ -8432,7 +8432,7 @@
     </p:spTree>
     <p:extLst>
       <p:ext uri="{BB962C8B-B14F-4D97-AF65-F5344CB8AC3E}">
-        <p14:creationId xmlns:p14="http://schemas.microsoft.com/office/powerpoint/2010/main" val="890663015"/>
+        <p14:creationId xmlns:p14="http://schemas.microsoft.com/office/powerpoint/2010/main" val="1012571792"/>
       </p:ext>
     </p:extLst>
   </p:cSld>
@@ -8463,7 +8463,7 @@
           <p:cNvPr id="11" name="">
             <a:extLst xmlns:a="http://schemas.openxmlformats.org/drawingml/2006/main">
               <a:ext uri="{FF2B5EF4-FFF2-40B4-BE49-F238E27FC236}">
-                <a16:creationId xmlns:a16="http://schemas.microsoft.com/office/drawing/2014/main" id="{5B5A255A-9A3D-4553-8385-D8BCD0F9F073}"/>
+                <a16:creationId xmlns:a16="http://schemas.microsoft.com/office/drawing/2014/main" id="{5EBDA016-9CBC-4FEE-A2D5-CA1F02EF4FAC}"/>
               </a:ext>
             </a:extLst>
           </p:cNvPr>
@@ -8531,7 +8531,7 @@
           <p:cNvPr id="2" name="">
             <a:extLst xmlns:a="http://schemas.openxmlformats.org/drawingml/2006/main">
               <a:ext uri="{FF2B5EF4-FFF2-40B4-BE49-F238E27FC236}">
-                <a16:creationId xmlns:a16="http://schemas.microsoft.com/office/drawing/2014/main" id="{612B5DD8-F2B1-46AF-A909-79F8A2DC6959}"/>
+                <a16:creationId xmlns:a16="http://schemas.microsoft.com/office/drawing/2014/main" id="{B405C632-AB1F-4295-8734-DF65D6690F60}"/>
               </a:ext>
             </a:extLst>
           </p:cNvPr>
@@ -8599,7 +8599,7 @@
           <p:cNvPr id="3" name="">
             <a:extLst xmlns:a="http://schemas.openxmlformats.org/drawingml/2006/main">
               <a:ext uri="{FF2B5EF4-FFF2-40B4-BE49-F238E27FC236}">
-                <a16:creationId xmlns:a16="http://schemas.microsoft.com/office/drawing/2014/main" id="{7D5DB897-7221-4BB1-B177-97463EE38430}"/>
+                <a16:creationId xmlns:a16="http://schemas.microsoft.com/office/drawing/2014/main" id="{AE901053-7EE5-4333-B31A-54F39071FBB6}"/>
               </a:ext>
             </a:extLst>
           </p:cNvPr>
@@ -8667,7 +8667,7 @@
           <p:cNvPr id="4" name="Chart">
             <a:extLst xmlns:a="http://schemas.openxmlformats.org/drawingml/2006/main">
               <a:ext uri="{FF2B5EF4-FFF2-40B4-BE49-F238E27FC236}">
-                <a16:creationId xmlns:a16="http://schemas.microsoft.com/office/drawing/2014/main" id="{693A6868-AD6A-41C0-A42B-B037A53CF534}"/>
+                <a16:creationId xmlns:a16="http://schemas.microsoft.com/office/drawing/2014/main" id="{C21FF4EC-137E-4AD1-8BF5-53143A23A73E}"/>
               </a:ext>
             </a:extLst>
           </p:cNvPr>
@@ -8680,7 +8680,7 @@
         </p:xfrm>
         <a:graphic xmlns:a="http://schemas.openxmlformats.org/drawingml/2006/main">
           <a:graphicData uri="http://schemas.openxmlformats.org/drawingml/2006/chart">
-            <c:chart xmlns:r="http://schemas.openxmlformats.org/officeDocument/2006/relationships" xmlns:c="http://schemas.openxmlformats.org/drawingml/2006/chart" r:id="Ref23cf776979480c"/>
+            <c:chart xmlns:r="http://schemas.openxmlformats.org/officeDocument/2006/relationships" xmlns:c="http://schemas.openxmlformats.org/drawingml/2006/chart" r:id="Re679224fc01847e6"/>
           </a:graphicData>
         </a:graphic>
       </p:graphicFrame>
@@ -8689,7 +8689,7 @@
           <p:cNvPr id="5" name="">
             <a:extLst xmlns:a="http://schemas.openxmlformats.org/drawingml/2006/main">
               <a:ext uri="{FF2B5EF4-FFF2-40B4-BE49-F238E27FC236}">
-                <a16:creationId xmlns:a16="http://schemas.microsoft.com/office/drawing/2014/main" id="{61C7BF5B-278F-445C-B53E-557A12D37FF7}"/>
+                <a16:creationId xmlns:a16="http://schemas.microsoft.com/office/drawing/2014/main" id="{DABA3FDC-F58F-4CA7-A4E5-49EF5B72B4DF}"/>
               </a:ext>
             </a:extLst>
           </p:cNvPr>
@@ -8757,7 +8757,7 @@
           <p:cNvPr id="6" name="">
             <a:extLst xmlns:a="http://schemas.openxmlformats.org/drawingml/2006/main">
               <a:ext uri="{FF2B5EF4-FFF2-40B4-BE49-F238E27FC236}">
-                <a16:creationId xmlns:a16="http://schemas.microsoft.com/office/drawing/2014/main" id="{DC9364CA-998B-4778-AAF5-FF5D62FE7E9B}"/>
+                <a16:creationId xmlns:a16="http://schemas.microsoft.com/office/drawing/2014/main" id="{BC274D03-320E-454C-AC6A-6B487F4BB63C}"/>
               </a:ext>
             </a:extLst>
           </p:cNvPr>
@@ -8825,7 +8825,7 @@
           <p:cNvPr id="7" name="">
             <a:extLst xmlns:a="http://schemas.openxmlformats.org/drawingml/2006/main">
               <a:ext uri="{FF2B5EF4-FFF2-40B4-BE49-F238E27FC236}">
-                <a16:creationId xmlns:a16="http://schemas.microsoft.com/office/drawing/2014/main" id="{E0E3A6EC-A2C6-4C8E-BFC8-5256D77B1D74}"/>
+                <a16:creationId xmlns:a16="http://schemas.microsoft.com/office/drawing/2014/main" id="{0EFA6FCE-A5B0-47BD-A721-B03F8AA74A69}"/>
               </a:ext>
             </a:extLst>
           </p:cNvPr>
@@ -8893,7 +8893,7 @@
           <p:cNvPr id="8" name="">
             <a:extLst xmlns:a="http://schemas.openxmlformats.org/drawingml/2006/main">
               <a:ext uri="{FF2B5EF4-FFF2-40B4-BE49-F238E27FC236}">
-                <a16:creationId xmlns:a16="http://schemas.microsoft.com/office/drawing/2014/main" id="{4B7A79BE-471B-482B-A8DF-82833B32053D}"/>
+                <a16:creationId xmlns:a16="http://schemas.microsoft.com/office/drawing/2014/main" id="{DF05DE58-5A66-45E7-AC6C-BC38895191B0}"/>
               </a:ext>
             </a:extLst>
           </p:cNvPr>
@@ -8961,7 +8961,7 @@
           <p:cNvPr id="9" name="">
             <a:extLst xmlns:a="http://schemas.openxmlformats.org/drawingml/2006/main">
               <a:ext uri="{FF2B5EF4-FFF2-40B4-BE49-F238E27FC236}">
-                <a16:creationId xmlns:a16="http://schemas.microsoft.com/office/drawing/2014/main" id="{7D4BE054-549C-42D1-9805-74BB3230E6C9}"/>
+                <a16:creationId xmlns:a16="http://schemas.microsoft.com/office/drawing/2014/main" id="{AC67FAF9-8056-486C-8B02-7ACDC52D8925}"/>
               </a:ext>
             </a:extLst>
           </p:cNvPr>
@@ -9029,7 +9029,7 @@
           <p:cNvPr id="10" name="">
             <a:extLst xmlns:a="http://schemas.openxmlformats.org/drawingml/2006/main">
               <a:ext uri="{FF2B5EF4-FFF2-40B4-BE49-F238E27FC236}">
-                <a16:creationId xmlns:a16="http://schemas.microsoft.com/office/drawing/2014/main" id="{5C483138-9E21-4594-A121-59E005E0D7B4}"/>
+                <a16:creationId xmlns:a16="http://schemas.microsoft.com/office/drawing/2014/main" id="{1538A680-ED77-46A5-805B-A29EA82FB8AA}"/>
               </a:ext>
             </a:extLst>
           </p:cNvPr>
@@ -9095,7 +9095,7 @@
     </p:spTree>
     <p:extLst>
       <p:ext uri="{BB962C8B-B14F-4D97-AF65-F5344CB8AC3E}">
-        <p14:creationId xmlns:p14="http://schemas.microsoft.com/office/powerpoint/2010/main" val="921169008"/>
+        <p14:creationId xmlns:p14="http://schemas.microsoft.com/office/powerpoint/2010/main" val="1915330165"/>
       </p:ext>
     </p:extLst>
   </p:cSld>
@@ -9126,7 +9126,7 @@
           <p:cNvPr id="13" name="">
             <a:extLst xmlns:a="http://schemas.openxmlformats.org/drawingml/2006/main">
               <a:ext uri="{FF2B5EF4-FFF2-40B4-BE49-F238E27FC236}">
-                <a16:creationId xmlns:a16="http://schemas.microsoft.com/office/drawing/2014/main" id="{14BC0872-7B41-4B70-BE65-08055BDAFD1D}"/>
+                <a16:creationId xmlns:a16="http://schemas.microsoft.com/office/drawing/2014/main" id="{4B55CFF9-B3C9-49F7-B4C4-6B7D7C61A34C}"/>
               </a:ext>
             </a:extLst>
           </p:cNvPr>
@@ -9194,7 +9194,7 @@
           <p:cNvPr id="2" name="">
             <a:extLst xmlns:a="http://schemas.openxmlformats.org/drawingml/2006/main">
               <a:ext uri="{FF2B5EF4-FFF2-40B4-BE49-F238E27FC236}">
-                <a16:creationId xmlns:a16="http://schemas.microsoft.com/office/drawing/2014/main" id="{459FB475-9BC1-4075-BF91-46518020D044}"/>
+                <a16:creationId xmlns:a16="http://schemas.microsoft.com/office/drawing/2014/main" id="{A891D7D8-8DE8-4FA2-AD87-EBCB9837BE9D}"/>
               </a:ext>
             </a:extLst>
           </p:cNvPr>
@@ -9262,7 +9262,7 @@
           <p:cNvPr id="3" name="">
             <a:extLst xmlns:a="http://schemas.openxmlformats.org/drawingml/2006/main">
               <a:ext uri="{FF2B5EF4-FFF2-40B4-BE49-F238E27FC236}">
-                <a16:creationId xmlns:a16="http://schemas.microsoft.com/office/drawing/2014/main" id="{FB777E4F-67CF-4AD2-AB91-264A2112D3CE}"/>
+                <a16:creationId xmlns:a16="http://schemas.microsoft.com/office/drawing/2014/main" id="{8047E4C2-5ED2-4B1A-BC6E-65BBB7B9C492}"/>
               </a:ext>
             </a:extLst>
           </p:cNvPr>
@@ -9330,7 +9330,7 @@
           <p:cNvPr id="4" name="">
             <a:extLst xmlns:a="http://schemas.openxmlformats.org/drawingml/2006/main">
               <a:ext uri="{FF2B5EF4-FFF2-40B4-BE49-F238E27FC236}">
-                <a16:creationId xmlns:a16="http://schemas.microsoft.com/office/drawing/2014/main" id="{F16F89D9-D13E-4F7E-A3B9-B807C35312CD}"/>
+                <a16:creationId xmlns:a16="http://schemas.microsoft.com/office/drawing/2014/main" id="{8CB030AF-DB7C-46CC-BA6F-5886A6CF21CA}"/>
               </a:ext>
             </a:extLst>
           </p:cNvPr>
@@ -9398,7 +9398,7 @@
           <p:cNvPr id="5" name="">
             <a:extLst xmlns:a="http://schemas.openxmlformats.org/drawingml/2006/main">
               <a:ext uri="{FF2B5EF4-FFF2-40B4-BE49-F238E27FC236}">
-                <a16:creationId xmlns:a16="http://schemas.microsoft.com/office/drawing/2014/main" id="{03C778B8-162A-4076-ADFD-BE43F2427CC5}"/>
+                <a16:creationId xmlns:a16="http://schemas.microsoft.com/office/drawing/2014/main" id="{8693E144-F8E7-4C3B-BB69-8888163C0B30}"/>
               </a:ext>
             </a:extLst>
           </p:cNvPr>
@@ -9466,7 +9466,7 @@
           <p:cNvPr id="6" name="">
             <a:extLst xmlns:a="http://schemas.openxmlformats.org/drawingml/2006/main">
               <a:ext uri="{FF2B5EF4-FFF2-40B4-BE49-F238E27FC236}">
-                <a16:creationId xmlns:a16="http://schemas.microsoft.com/office/drawing/2014/main" id="{BE0349B2-6A04-40B0-9C90-6B7031375A83}"/>
+                <a16:creationId xmlns:a16="http://schemas.microsoft.com/office/drawing/2014/main" id="{8A690868-01D2-4221-85AC-589CD8E4CAF2}"/>
               </a:ext>
             </a:extLst>
           </p:cNvPr>
@@ -9534,7 +9534,7 @@
           <p:cNvPr id="7" name="">
             <a:extLst xmlns:a="http://schemas.openxmlformats.org/drawingml/2006/main">
               <a:ext uri="{FF2B5EF4-FFF2-40B4-BE49-F238E27FC236}">
-                <a16:creationId xmlns:a16="http://schemas.microsoft.com/office/drawing/2014/main" id="{BE47DA4E-983D-45EE-9C0A-CF88D242A5CF}"/>
+                <a16:creationId xmlns:a16="http://schemas.microsoft.com/office/drawing/2014/main" id="{CFF34242-4105-4863-B7F2-F656DB875BF7}"/>
               </a:ext>
             </a:extLst>
           </p:cNvPr>
@@ -9602,7 +9602,7 @@
           <p:cNvPr id="8" name="">
             <a:extLst xmlns:a="http://schemas.openxmlformats.org/drawingml/2006/main">
               <a:ext uri="{FF2B5EF4-FFF2-40B4-BE49-F238E27FC236}">
-                <a16:creationId xmlns:a16="http://schemas.microsoft.com/office/drawing/2014/main" id="{077EDE57-2453-400B-AC2D-C51468703BF4}"/>
+                <a16:creationId xmlns:a16="http://schemas.microsoft.com/office/drawing/2014/main" id="{693A98B2-AB53-4E54-A7AF-5E7EB92F69A9}"/>
               </a:ext>
             </a:extLst>
           </p:cNvPr>
@@ -9660,7 +9660,7 @@
                 <a:ea typeface="Arial"/>
                 <a:cs typeface="Arial"/>
               </a:rPr>
-              <a:t>Verify a small EC2 deployment before attempting EKS.</a:t>
+              <a:t>Verified EC2 first. EKS needs a permitted account and budget.</a:t>
             </a:r>
           </a:p>
         </p:txBody>
@@ -9670,7 +9670,7 @@
           <p:cNvPr id="9" name="">
             <a:extLst xmlns:a="http://schemas.openxmlformats.org/drawingml/2006/main">
               <a:ext uri="{FF2B5EF4-FFF2-40B4-BE49-F238E27FC236}">
-                <a16:creationId xmlns:a16="http://schemas.microsoft.com/office/drawing/2014/main" id="{88BED26A-C278-428C-83E9-E1770F04C760}"/>
+                <a16:creationId xmlns:a16="http://schemas.microsoft.com/office/drawing/2014/main" id="{557047AA-EE49-45BB-BF19-E9364CB3CEB6}"/>
               </a:ext>
             </a:extLst>
           </p:cNvPr>
@@ -9738,7 +9738,7 @@
           <p:cNvPr id="10" name="">
             <a:extLst xmlns:a="http://schemas.openxmlformats.org/drawingml/2006/main">
               <a:ext uri="{FF2B5EF4-FFF2-40B4-BE49-F238E27FC236}">
-                <a16:creationId xmlns:a16="http://schemas.microsoft.com/office/drawing/2014/main" id="{255BF181-BB62-4D81-9BDD-6354A4B8BE34}"/>
+                <a16:creationId xmlns:a16="http://schemas.microsoft.com/office/drawing/2014/main" id="{0D3EB51C-17F9-4CB8-A2D0-E83F5F89CE02}"/>
               </a:ext>
             </a:extLst>
           </p:cNvPr>
@@ -9806,7 +9806,7 @@
           <p:cNvPr id="11" name="">
             <a:extLst xmlns:a="http://schemas.openxmlformats.org/drawingml/2006/main">
               <a:ext uri="{FF2B5EF4-FFF2-40B4-BE49-F238E27FC236}">
-                <a16:creationId xmlns:a16="http://schemas.microsoft.com/office/drawing/2014/main" id="{B5B27C35-AFB0-4148-9C5C-EFEB1D032DA0}"/>
+                <a16:creationId xmlns:a16="http://schemas.microsoft.com/office/drawing/2014/main" id="{C7A8EC53-EE16-4C68-923D-A23C629F9683}"/>
               </a:ext>
             </a:extLst>
           </p:cNvPr>
@@ -9874,7 +9874,7 @@
           <p:cNvPr id="12" name="">
             <a:extLst xmlns:a="http://schemas.openxmlformats.org/drawingml/2006/main">
               <a:ext uri="{FF2B5EF4-FFF2-40B4-BE49-F238E27FC236}">
-                <a16:creationId xmlns:a16="http://schemas.microsoft.com/office/drawing/2014/main" id="{10394FCF-975B-4125-998B-216FE30434F9}"/>
+                <a16:creationId xmlns:a16="http://schemas.microsoft.com/office/drawing/2014/main" id="{F441A6B8-D9EA-4401-AF3D-96FE553B885E}"/>
               </a:ext>
             </a:extLst>
           </p:cNvPr>
@@ -9940,7 +9940,7 @@
     </p:spTree>
     <p:extLst>
       <p:ext uri="{BB962C8B-B14F-4D97-AF65-F5344CB8AC3E}">
-        <p14:creationId xmlns:p14="http://schemas.microsoft.com/office/powerpoint/2010/main" val="1636491716"/>
+        <p14:creationId xmlns:p14="http://schemas.microsoft.com/office/powerpoint/2010/main" val="1033907175"/>
       </p:ext>
     </p:extLst>
   </p:cSld>
@@ -9971,7 +9971,7 @@
           <p:cNvPr id="5" name="">
             <a:extLst xmlns:a="http://schemas.openxmlformats.org/drawingml/2006/main">
               <a:ext uri="{FF2B5EF4-FFF2-40B4-BE49-F238E27FC236}">
-                <a16:creationId xmlns:a16="http://schemas.microsoft.com/office/drawing/2014/main" id="{29389B93-1942-4F02-B467-FD01D9F5272A}"/>
+                <a16:creationId xmlns:a16="http://schemas.microsoft.com/office/drawing/2014/main" id="{E04C703D-9918-4A23-85A1-39F313C2537D}"/>
               </a:ext>
             </a:extLst>
           </p:cNvPr>
@@ -10039,7 +10039,7 @@
           <p:cNvPr id="2" name="">
             <a:extLst xmlns:a="http://schemas.openxmlformats.org/drawingml/2006/main">
               <a:ext uri="{FF2B5EF4-FFF2-40B4-BE49-F238E27FC236}">
-                <a16:creationId xmlns:a16="http://schemas.microsoft.com/office/drawing/2014/main" id="{620D7F52-0A3C-46A5-9F62-3D4337715675}"/>
+                <a16:creationId xmlns:a16="http://schemas.microsoft.com/office/drawing/2014/main" id="{DACB5E11-6805-43AB-B435-4E17FBB6DA93}"/>
               </a:ext>
             </a:extLst>
           </p:cNvPr>
@@ -10107,7 +10107,7 @@
           <p:cNvPr id="3" name="">
             <a:extLst xmlns:a="http://schemas.openxmlformats.org/drawingml/2006/main">
               <a:ext uri="{FF2B5EF4-FFF2-40B4-BE49-F238E27FC236}">
-                <a16:creationId xmlns:a16="http://schemas.microsoft.com/office/drawing/2014/main" id="{984201E1-5357-4855-85D5-47E23ABDCA42}"/>
+                <a16:creationId xmlns:a16="http://schemas.microsoft.com/office/drawing/2014/main" id="{79FF24E0-1FC3-4CAB-A802-341F1BD2CD8F}"/>
               </a:ext>
             </a:extLst>
           </p:cNvPr>
@@ -10244,7 +10244,7 @@
           <p:cNvPr id="4" name="">
             <a:extLst xmlns:a="http://schemas.openxmlformats.org/drawingml/2006/main">
               <a:ext uri="{FF2B5EF4-FFF2-40B4-BE49-F238E27FC236}">
-                <a16:creationId xmlns:a16="http://schemas.microsoft.com/office/drawing/2014/main" id="{ED025011-1C76-46B2-A9EE-B6C9BC8C8F9E}"/>
+                <a16:creationId xmlns:a16="http://schemas.microsoft.com/office/drawing/2014/main" id="{E4672487-9013-4EE3-8DC0-61CA2CDE6D3F}"/>
               </a:ext>
             </a:extLst>
           </p:cNvPr>
@@ -10310,7 +10310,7 @@
     </p:spTree>
     <p:extLst>
       <p:ext uri="{BB962C8B-B14F-4D97-AF65-F5344CB8AC3E}">
-        <p14:creationId xmlns:p14="http://schemas.microsoft.com/office/powerpoint/2010/main" val="31450285"/>
+        <p14:creationId xmlns:p14="http://schemas.microsoft.com/office/powerpoint/2010/main" val="1921528697"/>
       </p:ext>
     </p:extLst>
   </p:cSld>

</xml_diff>